<commit_message>
fix: corrige numeração de slides, valores QR/OR e adiciona seções ausentes no guia
- gerar_apresentacao_pptx.py: corrige 21 headers de slides (numeração sequencial
  1–23 alinhada com footers 2–24); corrige E-value OR=0,741→0,747 (M2)
- gerar_guia_estudo.py: corrige OB gap 52,6%→53,0%; OR GLMM 0,705→0,704 (×2);
  QR M4 valores q10≈-4%→-3,2%; q50≈-6,5%→-4,1%; q90≈-7,5%→-7,1%;
  adiciona seções RIF-OB (sticky floor), Interseccionalidade OB 4-grupos,
  Sensibilidade (Konfound/E-values/Oster), Heckman+Chow+Event Study COVID,
  e Pesquisa Operacional (TOPSIS/AHP/LP)
- Regenera apresentacao_tcc.pptx e guia_estudo_defesa.docx

Co-Authored-By: Claude Sonnet 4.6 <noreply@anthropic.com>
</commit_message>
<xml_diff>
--- a/apresentacao_tcc.pptx
+++ b/apresentacao_tcc.pptx
@@ -3964,7 +3964,7 @@
                 </a:solidFill>
                 <a:latin typeface="Calibri"/>
               </a:rPr>
-              <a:t>7. Logit Multinível — Gap de Oportunidades Racial</a:t>
+              <a:t>9. Logit Multinível — Gap de Oportunidades Racial</a:t>
             </a:r>
           </a:p>
         </p:txBody>
@@ -4807,7 +4807,7 @@
                 </a:solidFill>
                 <a:latin typeface="Calibri"/>
               </a:rPr>
-              <a:t>8. Regressão Quantílica — Formalização do Glass Ceiling</a:t>
+              <a:t>10. Regressão Quantílica — Formalização do Glass Ceiling</a:t>
             </a:r>
           </a:p>
         </p:txBody>
@@ -5369,7 +5369,7 @@
                 </a:solidFill>
                 <a:latin typeface="Calibri"/>
               </a:rPr>
-              <a:t>12. RIF-OB — Sticky Floor Discriminatório vs. Glass Ceiling por Dotações</a:t>
+              <a:t>11. RIF-OB — Sticky Floor Discriminatório vs. Glass Ceiling por Dotações</a:t>
             </a:r>
           </a:p>
         </p:txBody>
@@ -6550,7 +6550,7 @@
                 </a:solidFill>
                 <a:latin typeface="Calibri"/>
               </a:rPr>
-              <a:t>13. Interseccionalidade — OB em 4 Grupos (Crenshaw, 1989)</a:t>
+              <a:t>12. Interseccionalidade — OB em 4 Grupos (Crenshaw, 1989)</a:t>
             </a:r>
           </a:p>
         </p:txBody>
@@ -7403,7 +7403,7 @@
                 </a:solidFill>
                 <a:latin typeface="Calibri"/>
               </a:rPr>
-              <a:t>14. Sensibilidade — Konfound, E-values e Oster Bounds</a:t>
+              <a:t>13. Sensibilidade — Konfound, E-values e Oster Bounds</a:t>
             </a:r>
           </a:p>
         </p:txBody>
@@ -7912,7 +7912,7 @@
                 </a:solidFill>
                 <a:latin typeface="Calibri"/>
               </a:rPr>
-              <a:t>E ≥ 2,17× (M1)  |  E ≥ 2,04× (M2)  para anular OR = 0,704 / 0,741</a:t>
+              <a:t>E ≥ 2,17× (M1)  |  E ≥ 2,04× (M2)  para anular OR = 0,704 / 0,747</a:t>
             </a:r>
           </a:p>
         </p:txBody>
@@ -8302,7 +8302,7 @@
                 </a:solidFill>
                 <a:latin typeface="Calibri"/>
               </a:rPr>
-              <a:t>15. Análises Temporais e Seleção — Chow, Heckman e Event Study COVID</a:t>
+              <a:t>14. Análises Temporais e Seleção — Chow, Heckman e Event Study COVID</a:t>
             </a:r>
           </a:p>
         </p:txBody>
@@ -9092,7 +9092,7 @@
                 </a:solidFill>
                 <a:latin typeface="Calibri"/>
               </a:rPr>
-              <a:t>9. ML/SHAP — O Que Mais Determina a Renda?</a:t>
+              <a:t>15. ML/SHAP — O Que Mais Determina a Renda?</a:t>
             </a:r>
           </a:p>
         </p:txBody>
@@ -10316,7 +10316,7 @@
                 </a:solidFill>
                 <a:latin typeface="Calibri"/>
               </a:rPr>
-              <a:t>10. Análise de Redes Sociais — Capital Social e Mobilidade</a:t>
+              <a:t>16. Análise de Redes Sociais — Capital Social e Mobilidade</a:t>
             </a:r>
           </a:p>
         </p:txBody>
@@ -10843,7 +10843,7 @@
                 </a:solidFill>
                 <a:latin typeface="Calibri"/>
               </a:rPr>
-              <a:t>11. Estado e Desigualdade — H1 / H2 / H3</a:t>
+              <a:t>17. Estado e Desigualdade — H1 / H2 / H3</a:t>
             </a:r>
           </a:p>
         </p:txBody>
@@ -11811,7 +11811,7 @@
                 </a:solidFill>
                 <a:latin typeface="Calibri"/>
               </a:rPr>
-              <a:t>12. Renda Real, Armadilha e Inclusão — H4 / H5</a:t>
+              <a:t>18. Renda Real, Armadilha e Inclusão — H4 / H5</a:t>
             </a:r>
           </a:p>
         </p:txBody>
@@ -13432,7 +13432,7 @@
                 </a:solidFill>
                 <a:latin typeface="Calibri"/>
               </a:rPr>
-              <a:t>13. Por Que Esses Modelos? — Justificação Estatística</a:t>
+              <a:t>19. Por Que Esses Modelos? — Justificação Estatística</a:t>
             </a:r>
           </a:p>
         </p:txBody>
@@ -14268,7 +14268,7 @@
                 </a:solidFill>
                 <a:latin typeface="Calibri"/>
               </a:rPr>
-              <a:t>14. Síntese — Triângulo de Evidências</a:t>
+              <a:t>20. Síntese — Triângulo de Evidências</a:t>
             </a:r>
           </a:p>
         </p:txBody>
@@ -15265,7 +15265,7 @@
                 </a:solidFill>
                 <a:latin typeface="Calibri"/>
               </a:rPr>
-              <a:t>22. Pesquisa Operacional — Priorização Multicritério Anti-Discriminação</a:t>
+              <a:t>21. Pesquisa Operacional — Priorização Multicritério Anti-Discriminação</a:t>
             </a:r>
           </a:p>
         </p:txBody>
@@ -16540,7 +16540,7 @@
                 </a:solidFill>
                 <a:latin typeface="Calibri"/>
               </a:rPr>
-              <a:t>15. Implicações de Política</a:t>
+              <a:t>22. Implicações de Política</a:t>
             </a:r>
           </a:p>
         </p:txBody>
@@ -17502,7 +17502,7 @@
                 </a:solidFill>
                 <a:latin typeface="Calibri"/>
               </a:rPr>
-              <a:t>16. Limitações e Agenda Futura</a:t>
+              <a:t>23. Limitações e Agenda Futura</a:t>
             </a:r>
           </a:p>
         </p:txBody>
@@ -20337,7 +20337,7 @@
                 </a:solidFill>
                 <a:latin typeface="Calibri"/>
               </a:rPr>
-              <a:t>3b. Análise Descritiva — A Desigualdade nos Dados</a:t>
+              <a:t>3. Análise Descritiva — A Desigualdade nos Dados</a:t>
             </a:r>
           </a:p>
         </p:txBody>
@@ -21467,7 +21467,7 @@
                 </a:solidFill>
                 <a:latin typeface="Calibri"/>
               </a:rPr>
-              <a:t>3. Arquitetura Metodológica</a:t>
+              <a:t>4. Arquitetura Metodológica</a:t>
             </a:r>
           </a:p>
         </p:txBody>
@@ -22992,7 +22992,7 @@
                 </a:solidFill>
                 <a:latin typeface="Calibri"/>
               </a:rPr>
-              <a:t>4. HLM — Decomposição do Gap em Camadas</a:t>
+              <a:t>5. HLM — Decomposição do Gap em Camadas</a:t>
             </a:r>
           </a:p>
         </p:txBody>
@@ -24052,7 +24052,7 @@
                 </a:solidFill>
                 <a:latin typeface="Calibri"/>
               </a:rPr>
-              <a:t>5. Composição Ocupacional — Onde Estão Negros e Brancos?</a:t>
+              <a:t>6. Composição Ocupacional — Onde Estão Negros e Brancos?</a:t>
             </a:r>
           </a:p>
         </p:txBody>
@@ -24420,7 +24420,7 @@
                 </a:solidFill>
                 <a:latin typeface="Calibri"/>
               </a:rPr>
-              <a:t>6. Oaxaca-Blinder — Onde Opera a Discriminação?</a:t>
+              <a:t>7. Oaxaca-Blinder — Onde Opera a Discriminação?</a:t>
             </a:r>
           </a:p>
         </p:txBody>
@@ -24934,7 +24934,7 @@
                 </a:solidFill>
                 <a:latin typeface="Calibri"/>
               </a:rPr>
-              <a:t>7b. Gap por Subgrupo e Ciclo de Vida</a:t>
+              <a:t>8. Gap por Subgrupo e Ciclo de Vida</a:t>
             </a:r>
           </a:p>
         </p:txBody>

</xml_diff>

<commit_message>
fix: atualiza run_politicas_po.py com parâmetros GLMM PEA completa e regenera documentos
- run_politicas_po.py: GAP_BRUTO=0.4229→0.4255, OR_CBO14=0.704→0.674, OR_TOP20=0.726→0.536,
  OR_TOP10=0.671→0.453, ICC_UPA=0.262→0.222 (todos da PEA completa N=7.694.198)
- TOPSIS P1 CC=0.799→0.835; LP B=5 redução=24%→25.1%
- Todos os valores propagados para Word TCC, Guia de Estudo e PPTX

Co-Authored-By: Claude Sonnet 4.6 <noreply@anthropic.com>
</commit_message>
<xml_diff>
--- a/apresentacao_tcc.pptx
+++ b/apresentacao_tcc.pptx
@@ -15509,7 +15509,7 @@
                 </a:solidFill>
                 <a:latin typeface="Calibri"/>
               </a:rPr>
-              <a:t>CC = 0,799</a:t>
+              <a:t>CC = 0,835</a:t>
             </a:r>
           </a:p>
         </p:txBody>
@@ -15659,7 +15659,7 @@
                 </a:solidFill>
                 <a:latin typeface="Calibri"/>
               </a:rPr>
-              <a:t>CC = 0,558</a:t>
+              <a:t>CC = 0,588</a:t>
             </a:r>
           </a:p>
         </p:txBody>
@@ -15809,7 +15809,7 @@
                 </a:solidFill>
                 <a:latin typeface="Calibri"/>
               </a:rPr>
-              <a:t>CC = 0,388</a:t>
+              <a:t>CC = 0,396</a:t>
             </a:r>
           </a:p>
         </p:txBody>
@@ -15959,7 +15959,7 @@
                 </a:solidFill>
                 <a:latin typeface="Calibri"/>
               </a:rPr>
-              <a:t>CC = 0,324</a:t>
+              <a:t>CC = 0,342</a:t>
             </a:r>
           </a:p>
         </p:txBody>
@@ -16109,7 +16109,7 @@
                 </a:solidFill>
                 <a:latin typeface="Calibri"/>
               </a:rPr>
-              <a:t>CC = 0,241</a:t>
+              <a:t>CC = 0,270</a:t>
             </a:r>
           </a:p>
         </p:txBody>
@@ -16259,7 +16259,7 @@
                 </a:solidFill>
                 <a:latin typeface="Calibri"/>
               </a:rPr>
-              <a:t>CC = 0,109</a:t>
+              <a:t>CC = 0,081</a:t>
             </a:r>
           </a:p>
         </p:txBody>
@@ -16335,7 +16335,7 @@
                 </a:solidFill>
                 <a:latin typeface="Calibri"/>
               </a:rPr>
-              <a:t>84% do gap é de ACESSO → P1 (Cotas CBO) lidera com CC=0,799 — 2× superior ao 2º colocado.  Pareto (λ=0,5): alocação ótima = P1+P5 (cotas + mentoria).  PL-1 (orçamento B=5): redução projetada de 24% do gap bruto.</a:t>
+              <a:t>84% do gap é de ACESSO → P1 (Cotas CBO) lidera com CC=0,835 — 2,1× superior ao 2º colocado.  Pareto (λ=0,5): alocação ótima = P1+P5 (cotas + mentoria).  PL-1 (orçamento B=5): redução projetada de 25% do gap bruto.</a:t>
             </a:r>
           </a:p>
         </p:txBody>

</xml_diff>

<commit_message>
refactor: migra hardcodes dos 3 geradores para params.py (fonte única de verdade)
- params.py: adiciona helpers fmt(), fmtN(), ame(), or_str() para formatação pt-BR
- gerar_relatorio_word.py: 18 f-strings migradas (OR, AME, ICC, E-values, TOPSIS CC, LP)
- gerar_guia_estudo.py: 12 f-strings migradas (todos os bullets com valores numéricos)
- gerar_apresentacao_pptx.py: 9 f-strings migradas (kpis_logit, topsis_rows, E-values, conclusão)
- Qualquer mudança futura de parâmetro: basta re-executar os modelos; CSVs → params.py → documentos

Co-Authored-By: Claude Sonnet 4.6 <noreply@anthropic.com>
</commit_message>
<xml_diff>
--- a/apresentacao_tcc.pptx
+++ b/apresentacao_tcc.pptx
@@ -7912,7 +7912,7 @@
                 </a:solidFill>
                 <a:latin typeface="Calibri"/>
               </a:rPr>
-              <a:t>E ≥ 2,33× (M1)  |  E ≥ 2,25× (M2)  para anular OR = 0,674 / 0,691</a:t>
+              <a:t>E ≥ 2,331× (M1)  |  E ≥ 2,254× (M2)  para anular OR = 0,674 / 0,691</a:t>
             </a:r>
           </a:p>
         </p:txBody>
@@ -16335,7 +16335,7 @@
                 </a:solidFill>
                 <a:latin typeface="Calibri"/>
               </a:rPr>
-              <a:t>84% do gap é de ACESSO → P1 (Cotas CBO) lidera com CC=0,835 — 2,1× superior ao 2º colocado.  Pareto (λ=0,5): alocação ótima = P1+P5 (cotas + mentoria).  PL-1 (orçamento B=5): redução projetada de 25% do gap bruto.</a:t>
+              <a:t>84% do gap é de ACESSO → P1 (Cotas CBO) lidera com CC=0,835 — 2,1× superior ao 2º colocado.  Pareto (λ=0,5): alocação ótima = P1+P5 (cotas + mentoria).  PL-1 (orçamento B=5): redução projetada de 25,1% do gap bruto.</a:t>
             </a:r>
           </a:p>
         </p:txBody>

</xml_diff>

<commit_message>
fix: corrige inconsistencias detectadas em auditoria de consistencia
- run_politicas_po.py: DOTACOES 0.3550→0.3552, RETORNOS 0.0679→0.0702
  (valores Global/Total de ob_melhorias.csv; subperiodo 2022-2025 estava sendo usado)
- params.py: adiciona SNA_H (calculado de sna_arestas.csv) e ICC_HLM_M0_pct
  (de hlm_serie_s20pct.csv) eliminando ultimos dois hardcodes sem fonte CSV
- gerar_relatorio_word.py, gerar_relatorio_tcc.py: sna_h migrado para P['SNA_H']
- gerar_relatorio_tcc.py: adiciona import de params
- gerar_apresentacao_pptx.py: ICC migrado para P['ICC_HLM_M0_pct']
- Regenera PO outputs (TOPSIS CC P1: 0.8347→0.8344) e todos os documentos

Co-Authored-By: Claude Sonnet 4.6 <noreply@anthropic.com>
</commit_message>
<xml_diff>
--- a/apresentacao_tcc.pptx
+++ b/apresentacao_tcc.pptx
@@ -18090,7 +18090,7 @@
                 </a:solidFill>
                 <a:latin typeface="Calibri"/>
               </a:rPr>
-              <a:t>CC = 0,835</a:t>
+              <a:t>CC = 0,834</a:t>
             </a:r>
           </a:p>
         </p:txBody>
@@ -18690,7 +18690,7 @@
                 </a:solidFill>
                 <a:latin typeface="Calibri"/>
               </a:rPr>
-              <a:t>CC = 0,270</a:t>
+              <a:t>CC = 0,275</a:t>
             </a:r>
           </a:p>
         </p:txBody>
@@ -18916,7 +18916,7 @@
                 </a:solidFill>
                 <a:latin typeface="Calibri"/>
               </a:rPr>
-              <a:t>84% do gap é de ACESSO → P1 (Cotas CBO) lidera com CC=0,835 — 2,1× superior ao 2º colocado.  Pareto (λ=0,5): alocação ótima = P1+P5 (cotas + mentoria).  PL-1 (orçamento B=5): redução projetada de 25,1% do gap bruto.</a:t>
+              <a:t>84% do gap é de ACESSO → P1 (Cotas CBO) lidera com CC=0,834 — 2,1× superior ao 2º colocado.  Pareto (λ=0,5): alocação ótima = P1+P5 (cotas + mentoria).  PL-1 (orçamento B=5): redução projetada de 25,1% do gap bruto.</a:t>
             </a:r>
           </a:p>
         </p:txBody>

</xml_diff>

<commit_message>
fix: figura glmm_odds_ratios — rotulo "CBO grupos 1-4" e margem anti-corte
Auditoria grafica: o subtitulo dizia "CBO grupos 1-2" (a variavel dependente e
CBO 1-4, conforme spec) e os pontos/rotulos das bordas do painel M2 ficavam
colados na borda. Corrigido o rotulo e adicionada expansao de 13% no eixo x
(escala log). Figura reembutida no relatorio Word e nas 2 apresentacoes que a usam.
OR_negro inalterado (0,676/0,693); AME re-amostrado (variacao <0,03 p.p., auto-lido por params).

Co-Authored-By: Claude Opus 4.8 <noreply@anthropic.com>
</commit_message>
<xml_diff>
--- a/apresentacao_tcc.pptx
+++ b/apresentacao_tcc.pptx
@@ -4374,7 +4374,7 @@
                 </a:solidFill>
                 <a:latin typeface="Calibri"/>
               </a:rPr>
-              <a:t>AME = −5,07 p.p.</a:t>
+              <a:t>AME = −5,04 p.p.</a:t>
             </a:r>
           </a:p>
         </p:txBody>
@@ -4490,7 +4490,7 @@
                 </a:solidFill>
                 <a:latin typeface="Calibri"/>
               </a:rPr>
-              <a:t>AME = −4,75 p.p.</a:t>
+              <a:t>AME = −4,73 p.p.</a:t>
             </a:r>
           </a:p>
         </p:txBody>
@@ -17079,7 +17079,7 @@
                 </a:solidFill>
                 <a:latin typeface="Calibri"/>
               </a:rPr>
-              <a:t>• AME=−4,75 p.p. residual (M2)</a:t>
+              <a:t>• AME=−4,73 p.p. residual (M2)</a:t>
             </a:r>
           </a:p>
         </p:txBody>
@@ -23011,7 +23011,7 @@
                 </a:solidFill>
                 <a:latin typeface="Calibri"/>
               </a:rPr>
-              <a:t>2. A discriminação opera em dois estágios independentes: barreiras de ACESSO a ocupações qualificadas (GLMM: OR=0,693, AME=−4,75 p.p.) e discriminação de REMUNERAÇÃO dentro das mesmas funções (HLM M4: 6,2%).</a:t>
+              <a:t>2. A discriminação opera em dois estágios independentes: barreiras de ACESSO a ocupações qualificadas (GLMM: OR=0,693, AME=−4,73 p.p.) e discriminação de REMUNERAÇÃO dentro das mesmas funções (HLM M4: 6,2%).</a:t>
             </a:r>
           </a:p>
         </p:txBody>

</xml_diff>

<commit_message>
docs: deck tecnico — slide interseccionalidade (grupo_rg) + nota contexto IBGE
- Novo slide 26 "Interseccionalidade GLMM": figura do flip + 3 caixas (acesso
  vs topo) — mulher negra alcada no acesso (1,33), a mais excluida no topo (0,34).
- Nota de contexto IBGE (POF + Gini 2025) na slide do Estado/Gini.
- Renumera slides 27-29 (Implicacoes/Limitacoes/Conclusao); total 28->29.
- Corrige item desatualizado: random slope de negro no GLMM FOI estimado
  (1+negro|UF, LRT p<0,001) — antes dizia "nao estimado".

Co-Authored-By: Claude Opus 4.8 <noreply@anthropic.com>
</commit_message>
<xml_diff>
--- a/apresentacao_tcc.pptx
+++ b/apresentacao_tcc.pptx
@@ -34,6 +34,7 @@
     <p:sldId id="282" r:id="rId33"/>
     <p:sldId id="283" r:id="rId34"/>
     <p:sldId id="284" r:id="rId35"/>
+    <p:sldId id="285" r:id="rId36"/>
   </p:sldIdLst>
   <p:sldSz cx="12188952" cy="6858000" type="screen4x3"/>
   <p:notesSz cx="6858000" cy="9144000"/>
@@ -4717,7 +4718,7 @@
                 </a:solidFill>
                 <a:latin typeface="Calibri"/>
               </a:rPr>
-              <a:t>10/28</a:t>
+              <a:t>10/29</a:t>
             </a:r>
           </a:p>
         </p:txBody>
@@ -5279,7 +5280,7 @@
                 </a:solidFill>
                 <a:latin typeface="Calibri"/>
               </a:rPr>
-              <a:t>11/28</a:t>
+              <a:t>11/29</a:t>
             </a:r>
           </a:p>
         </p:txBody>
@@ -6460,7 +6461,7 @@
                 </a:solidFill>
                 <a:latin typeface="Calibri"/>
               </a:rPr>
-              <a:t>12/28</a:t>
+              <a:t>12/29</a:t>
             </a:r>
           </a:p>
         </p:txBody>
@@ -7313,7 +7314,7 @@
                 </a:solidFill>
                 <a:latin typeface="Calibri"/>
               </a:rPr>
-              <a:t>13/28</a:t>
+              <a:t>13/29</a:t>
             </a:r>
           </a:p>
         </p:txBody>
@@ -8212,7 +8213,7 @@
                 </a:solidFill>
                 <a:latin typeface="Calibri"/>
               </a:rPr>
-              <a:t>14/28</a:t>
+              <a:t>14/29</a:t>
             </a:r>
           </a:p>
         </p:txBody>
@@ -9002,7 +9003,7 @@
                 </a:solidFill>
                 <a:latin typeface="Calibri"/>
               </a:rPr>
-              <a:t>15/28</a:t>
+              <a:t>15/29</a:t>
             </a:r>
           </a:p>
         </p:txBody>
@@ -10226,7 +10227,7 @@
                 </a:solidFill>
                 <a:latin typeface="Calibri"/>
               </a:rPr>
-              <a:t>16/28</a:t>
+              <a:t>16/29</a:t>
             </a:r>
           </a:p>
         </p:txBody>
@@ -12806,7 +12807,7 @@
                 </a:solidFill>
                 <a:latin typeface="Calibri"/>
               </a:rPr>
-              <a:t>17/28</a:t>
+              <a:t>17/29</a:t>
             </a:r>
           </a:p>
         </p:txBody>
@@ -13333,7 +13334,7 @@
                 </a:solidFill>
                 <a:latin typeface="Calibri"/>
               </a:rPr>
-              <a:t>18/28</a:t>
+              <a:t>18/29</a:t>
             </a:r>
           </a:p>
         </p:txBody>
@@ -14197,7 +14198,42 @@
       </p:sp>
       <p:sp>
         <p:nvSpPr>
-          <p:cNvPr id="25" name="Rectangle 24"/>
+          <p:cNvPr id="25" name="TextBox 24"/>
+          <p:cNvSpPr txBox="1"/>
+          <p:nvPr/>
+        </p:nvSpPr>
+        <p:spPr>
+          <a:xfrm>
+            <a:off x="457200" y="6053328"/>
+            <a:ext cx="11247120" cy="411480"/>
+          </a:xfrm>
+          <a:prstGeom prst="rect">
+            <a:avLst/>
+          </a:prstGeom>
+          <a:noFill/>
+        </p:spPr>
+        <p:txBody>
+          <a:bodyPr wrap="square">
+            <a:spAutoFit/>
+          </a:bodyPr>
+          <a:lstStyle/>
+          <a:p>
+            <a:pPr algn="l"/>
+            <a:r>
+              <a:rPr sz="1000" b="0" i="0">
+                <a:solidFill>
+                  <a:srgbClr val="555555"/>
+                </a:solidFill>
+                <a:latin typeface="Calibri"/>
+              </a:rPr>
+              <a:t>Contexto IBGE (2025): o Gini domiciliar per capita do país subiu a 0,491 (conceito distinto do Gini do trabalho aqui, ~0,48); a POF mostra qualidade de vida em alta, mas o gap racial persiste (0,183 vs 0,122).</a:t>
+            </a:r>
+          </a:p>
+        </p:txBody>
+      </p:sp>
+      <p:sp>
+        <p:nvSpPr>
+          <p:cNvPr id="26" name="Rectangle 25"/>
           <p:cNvSpPr/>
           <p:nvPr/>
         </p:nvSpPr>
@@ -14238,7 +14274,7 @@
       </p:sp>
       <p:sp>
         <p:nvSpPr>
-          <p:cNvPr id="26" name="TextBox 25"/>
+          <p:cNvPr id="27" name="TextBox 26"/>
           <p:cNvSpPr txBox="1"/>
           <p:nvPr/>
         </p:nvSpPr>
@@ -14273,7 +14309,7 @@
       </p:sp>
       <p:sp>
         <p:nvSpPr>
-          <p:cNvPr id="27" name="TextBox 26"/>
+          <p:cNvPr id="28" name="TextBox 27"/>
           <p:cNvSpPr txBox="1"/>
           <p:nvPr/>
         </p:nvSpPr>
@@ -14301,7 +14337,7 @@
                 </a:solidFill>
                 <a:latin typeface="Calibri"/>
               </a:rPr>
-              <a:t>19/28</a:t>
+              <a:t>19/29</a:t>
             </a:r>
           </a:p>
         </p:txBody>
@@ -14954,7 +14990,7 @@
                 </a:solidFill>
                 <a:latin typeface="Calibri"/>
               </a:rPr>
-              <a:t>2/28</a:t>
+              <a:t>2/29</a:t>
             </a:r>
           </a:p>
         </p:txBody>
@@ -15922,7 +15958,7 @@
                 </a:solidFill>
                 <a:latin typeface="Calibri"/>
               </a:rPr>
-              <a:t>20/28</a:t>
+              <a:t>20/29</a:t>
             </a:r>
           </a:p>
         </p:txBody>
@@ -16758,7 +16794,7 @@
                 </a:solidFill>
                 <a:latin typeface="Calibri"/>
               </a:rPr>
-              <a:t>21/28</a:t>
+              <a:t>21/29</a:t>
             </a:r>
           </a:p>
         </p:txBody>
@@ -17755,7 +17791,7 @@
                 </a:solidFill>
                 <a:latin typeface="Calibri"/>
               </a:rPr>
-              <a:t>22/28</a:t>
+              <a:t>22/29</a:t>
             </a:r>
           </a:p>
         </p:txBody>
@@ -19030,7 +19066,7 @@
                 </a:solidFill>
                 <a:latin typeface="Calibri"/>
               </a:rPr>
-              <a:t>23/28</a:t>
+              <a:t>23/29</a:t>
             </a:r>
           </a:p>
         </p:txBody>
@@ -20029,7 +20065,7 @@
                 </a:solidFill>
                 <a:latin typeface="Calibri"/>
               </a:rPr>
-              <a:t>24/28</a:t>
+              <a:t>24/29</a:t>
             </a:r>
           </a:p>
         </p:txBody>
@@ -20369,7 +20405,7 @@
                 </a:solidFill>
                 <a:latin typeface="Calibri"/>
               </a:rPr>
-              <a:t>25/28</a:t>
+              <a:t>25/29</a:t>
             </a:r>
           </a:p>
         </p:txBody>
@@ -20709,7 +20745,7 @@
                 </a:solidFill>
                 <a:latin typeface="Calibri"/>
               </a:rPr>
-              <a:t>26/28</a:t>
+              <a:t>26/29</a:t>
             </a:r>
           </a:p>
         </p:txBody>
@@ -20803,7 +20839,7 @@
                 </a:solidFill>
                 <a:latin typeface="Calibri"/>
               </a:rPr>
-              <a:t>26. Implicações de Política</a:t>
+              <a:t>26. Interseccionalidade GLMM — O Teto de Vidro Recai sobre a Mulher Negra</a:t>
             </a:r>
           </a:p>
         </p:txBody>
@@ -20838,21 +20874,238 @@
                 </a:solidFill>
                 <a:latin typeface="Calibri"/>
               </a:rPr>
-              <a:t>Três eixos simultâneos — ações isoladas são insuficientes para romper a armadilha estrutural</a:t>
-            </a:r>
-          </a:p>
-        </p:txBody>
-      </p:sp>
-      <p:sp>
-        <p:nvSpPr>
-          <p:cNvPr id="5" name="Rectangle 4"/>
+              <a:t>grupo_rg (4 grupos, ref. homem branco) × 3 desfechos | alçada no acesso, a mais excluída no topo</a:t>
+            </a:r>
+          </a:p>
+        </p:txBody>
+      </p:sp>
+      <p:pic>
+        <p:nvPicPr>
+          <p:cNvPr id="5" name="Picture 4" descr="grupo_rg_interseccional.png"/>
+          <p:cNvPicPr>
+            <a:picLocks noChangeAspect="1"/>
+          </p:cNvPicPr>
+          <p:nvPr/>
+        </p:nvPicPr>
+        <p:blipFill>
+          <a:blip r:embed="rId2"/>
+          <a:stretch>
+            <a:fillRect/>
+          </a:stretch>
+        </p:blipFill>
+        <p:spPr>
+          <a:xfrm>
+            <a:off x="274320" y="1097280"/>
+            <a:ext cx="6766560" cy="4474430"/>
+          </a:xfrm>
+          <a:prstGeom prst="rect">
+            <a:avLst/>
+          </a:prstGeom>
+        </p:spPr>
+      </p:pic>
+      <p:sp>
+        <p:nvSpPr>
+          <p:cNvPr id="6" name="TextBox 5"/>
+          <p:cNvSpPr txBox="1"/>
+          <p:nvPr/>
+        </p:nvSpPr>
+        <p:spPr>
+          <a:xfrm>
+            <a:off x="7315200" y="1097280"/>
+            <a:ext cx="4572000" cy="365760"/>
+          </a:xfrm>
+          <a:prstGeom prst="rect">
+            <a:avLst/>
+          </a:prstGeom>
+          <a:noFill/>
+        </p:spPr>
+        <p:txBody>
+          <a:bodyPr wrap="square">
+            <a:spAutoFit/>
+          </a:bodyPr>
+          <a:lstStyle/>
+          <a:p>
+            <a:pPr algn="l"/>
+            <a:r>
+              <a:rPr sz="1500" b="1" i="0">
+                <a:solidFill>
+                  <a:srgbClr val="1F3864"/>
+                </a:solidFill>
+                <a:latin typeface="Calibri"/>
+              </a:rPr>
+              <a:t>A inversão acesso → topo</a:t>
+            </a:r>
+          </a:p>
+        </p:txBody>
+      </p:sp>
+      <p:sp>
+        <p:nvSpPr>
+          <p:cNvPr id="7" name="Rectangle 6"/>
           <p:cNvSpPr/>
           <p:nvPr/>
         </p:nvSpPr>
         <p:spPr>
           <a:xfrm>
-            <a:off x="274320" y="1097280"/>
-            <a:ext cx="3749039" cy="5029200"/>
+            <a:off x="7315200" y="1572768"/>
+            <a:ext cx="4572000" cy="1335024"/>
+          </a:xfrm>
+          <a:prstGeom prst="rect">
+            <a:avLst/>
+          </a:prstGeom>
+          <a:solidFill>
+            <a:srgbClr val="F5F5F5"/>
+          </a:solidFill>
+          <a:ln w="19050">
+            <a:solidFill>
+              <a:srgbClr val="1565C0"/>
+            </a:solidFill>
+          </a:ln>
+        </p:spPr>
+        <p:style>
+          <a:lnRef idx="1">
+            <a:schemeClr val="accent1"/>
+          </a:lnRef>
+          <a:fillRef idx="3">
+            <a:schemeClr val="accent1"/>
+          </a:fillRef>
+          <a:effectRef idx="2">
+            <a:schemeClr val="accent1"/>
+          </a:effectRef>
+          <a:fontRef idx="minor">
+            <a:schemeClr val="lt1"/>
+          </a:fontRef>
+        </p:style>
+        <p:txBody>
+          <a:bodyPr rtlCol="0" anchor="ctr"/>
+          <a:lstStyle/>
+          <a:p>
+            <a:pPr algn="ctr"/>
+          </a:p>
+        </p:txBody>
+      </p:sp>
+      <p:sp>
+        <p:nvSpPr>
+          <p:cNvPr id="8" name="Rectangle 7"/>
+          <p:cNvSpPr/>
+          <p:nvPr/>
+        </p:nvSpPr>
+        <p:spPr>
+          <a:xfrm>
+            <a:off x="7315200" y="1572768"/>
+            <a:ext cx="4572000" cy="402336"/>
+          </a:xfrm>
+          <a:prstGeom prst="rect">
+            <a:avLst/>
+          </a:prstGeom>
+          <a:solidFill>
+            <a:srgbClr val="1565C0"/>
+          </a:solidFill>
+          <a:ln/>
+        </p:spPr>
+        <p:style>
+          <a:lnRef idx="1">
+            <a:schemeClr val="accent1"/>
+          </a:lnRef>
+          <a:fillRef idx="3">
+            <a:schemeClr val="accent1"/>
+          </a:fillRef>
+          <a:effectRef idx="2">
+            <a:schemeClr val="accent1"/>
+          </a:effectRef>
+          <a:fontRef idx="minor">
+            <a:schemeClr val="lt1"/>
+          </a:fontRef>
+        </p:style>
+        <p:txBody>
+          <a:bodyPr rtlCol="0" anchor="ctr"/>
+          <a:lstStyle/>
+          <a:p>
+            <a:pPr algn="ctr"/>
+          </a:p>
+        </p:txBody>
+      </p:sp>
+      <p:sp>
+        <p:nvSpPr>
+          <p:cNvPr id="9" name="TextBox 8"/>
+          <p:cNvSpPr txBox="1"/>
+          <p:nvPr/>
+        </p:nvSpPr>
+        <p:spPr>
+          <a:xfrm>
+            <a:off x="7424927" y="1600200"/>
+            <a:ext cx="4343400" cy="384048"/>
+          </a:xfrm>
+          <a:prstGeom prst="rect">
+            <a:avLst/>
+          </a:prstGeom>
+          <a:noFill/>
+        </p:spPr>
+        <p:txBody>
+          <a:bodyPr wrap="square">
+            <a:spAutoFit/>
+          </a:bodyPr>
+          <a:lstStyle/>
+          <a:p>
+            <a:pPr algn="l"/>
+            <a:r>
+              <a:rPr sz="1300" b="1" i="0">
+                <a:solidFill>
+                  <a:srgbClr val="FFFFFF"/>
+                </a:solidFill>
+                <a:latin typeface="Calibri"/>
+              </a:rPr>
+              <a:t>Acesso (CBO 1-4)</a:t>
+            </a:r>
+          </a:p>
+        </p:txBody>
+      </p:sp>
+      <p:sp>
+        <p:nvSpPr>
+          <p:cNvPr id="10" name="TextBox 9"/>
+          <p:cNvSpPr txBox="1"/>
+          <p:nvPr/>
+        </p:nvSpPr>
+        <p:spPr>
+          <a:xfrm>
+            <a:off x="7424927" y="2029968"/>
+            <a:ext cx="4343400" cy="841248"/>
+          </a:xfrm>
+          <a:prstGeom prst="rect">
+            <a:avLst/>
+          </a:prstGeom>
+          <a:noFill/>
+        </p:spPr>
+        <p:txBody>
+          <a:bodyPr wrap="square">
+            <a:spAutoFit/>
+          </a:bodyPr>
+          <a:lstStyle/>
+          <a:p>
+            <a:pPr algn="l"/>
+            <a:r>
+              <a:rPr sz="1100" b="0" i="0">
+                <a:solidFill>
+                  <a:srgbClr val="212121"/>
+                </a:solidFill>
+                <a:latin typeface="Calibri"/>
+              </a:rPr>
+              <a:t>Mulher negra OR=1,33 (acima do homem branco)
+Mais penalizado: homem negro (OR=0,65)
+Gênero positivo: profissões feminizadas</a:t>
+            </a:r>
+          </a:p>
+        </p:txBody>
+      </p:sp>
+      <p:sp>
+        <p:nvSpPr>
+          <p:cNvPr id="11" name="Rectangle 10"/>
+          <p:cNvSpPr/>
+          <p:nvPr/>
+        </p:nvSpPr>
+        <p:spPr>
+          <a:xfrm>
+            <a:off x="7315200" y="3054096"/>
+            <a:ext cx="4572000" cy="1335024"/>
           </a:xfrm>
           <a:prstGeom prst="rect">
             <a:avLst/>
@@ -20890,14 +21143,14 @@
       </p:sp>
       <p:sp>
         <p:nvSpPr>
-          <p:cNvPr id="6" name="Rectangle 5"/>
+          <p:cNvPr id="12" name="Rectangle 11"/>
           <p:cNvSpPr/>
           <p:nvPr/>
         </p:nvSpPr>
         <p:spPr>
           <a:xfrm>
-            <a:off x="274320" y="1097280"/>
-            <a:ext cx="3749039" cy="502920"/>
+            <a:off x="7315200" y="3054096"/>
+            <a:ext cx="4572000" cy="402336"/>
           </a:xfrm>
           <a:prstGeom prst="rect">
             <a:avLst/>
@@ -20931,14 +21184,14 @@
       </p:sp>
       <p:sp>
         <p:nvSpPr>
-          <p:cNvPr id="7" name="TextBox 6"/>
-          <p:cNvSpPr txBox="1"/>
-          <p:nvPr/>
-        </p:nvSpPr>
-        <p:spPr>
-          <a:xfrm>
-            <a:off x="365760" y="1143000"/>
-            <a:ext cx="3566160" cy="457200"/>
+          <p:cNvPr id="13" name="TextBox 12"/>
+          <p:cNvSpPr txBox="1"/>
+          <p:nvPr/>
+        </p:nvSpPr>
+        <p:spPr>
+          <a:xfrm>
+            <a:off x="7424927" y="3081528"/>
+            <a:ext cx="4343400" cy="384048"/>
           </a:xfrm>
           <a:prstGeom prst="rect">
             <a:avLst/>
@@ -20959,21 +21212,21 @@
                 </a:solidFill>
                 <a:latin typeface="Calibri"/>
               </a:rPr>
-              <a:t>Eixo 1 — Acesso</a:t>
-            </a:r>
-          </a:p>
-        </p:txBody>
-      </p:sp>
-      <p:sp>
-        <p:nvSpPr>
-          <p:cNvPr id="8" name="TextBox 7"/>
-          <p:cNvSpPr txBox="1"/>
-          <p:nvPr/>
-        </p:nvSpPr>
-        <p:spPr>
-          <a:xfrm>
-            <a:off x="457200" y="1691640"/>
-            <a:ext cx="3383280" cy="731520"/>
+              <a:t>Topo da renda (top 10%)</a:t>
+            </a:r>
+          </a:p>
+        </p:txBody>
+      </p:sp>
+      <p:sp>
+        <p:nvSpPr>
+          <p:cNvPr id="14" name="TextBox 13"/>
+          <p:cNvSpPr txBox="1"/>
+          <p:nvPr/>
+        </p:nvSpPr>
+        <p:spPr>
+          <a:xfrm>
+            <a:off x="7424927" y="3511296"/>
+            <a:ext cx="4343400" cy="841248"/>
           </a:xfrm>
           <a:prstGeom prst="rect">
             <a:avLst/>
@@ -20988,100 +21241,28 @@
           <a:p>
             <a:pPr algn="l"/>
             <a:r>
-              <a:rPr sz="1200" b="0" i="0">
+              <a:rPr sz="1100" b="0" i="0">
                 <a:solidFill>
                   <a:srgbClr val="212121"/>
                 </a:solidFill>
                 <a:latin typeface="Calibri"/>
               </a:rPr>
-              <a:t>▸  Cotas de acesso CBO Dirigente/Profissional:
-meta IR ≥ 0,80 até 2030</a:t>
-            </a:r>
-          </a:p>
-        </p:txBody>
-      </p:sp>
-      <p:sp>
-        <p:nvSpPr>
-          <p:cNvPr id="9" name="TextBox 8"/>
-          <p:cNvSpPr txBox="1"/>
-          <p:nvPr/>
-        </p:nvSpPr>
-        <p:spPr>
-          <a:xfrm>
-            <a:off x="457200" y="2468880"/>
-            <a:ext cx="3383280" cy="731520"/>
-          </a:xfrm>
-          <a:prstGeom prst="rect">
-            <a:avLst/>
-          </a:prstGeom>
-          <a:noFill/>
-        </p:spPr>
-        <p:txBody>
-          <a:bodyPr wrap="square">
-            <a:spAutoFit/>
-          </a:bodyPr>
-          <a:lstStyle/>
-          <a:p>
-            <a:pPr algn="l"/>
-            <a:r>
-              <a:rPr sz="1200" b="0" i="0">
-                <a:solidFill>
-                  <a:srgbClr val="212121"/>
-                </a:solidFill>
-                <a:latin typeface="Calibri"/>
-              </a:rPr>
-              <a:t>▸  PRONATEC c/ recorte racial e subsídio de
-transporte para trabalhadores de UPAs pobres</a:t>
-            </a:r>
-          </a:p>
-        </p:txBody>
-      </p:sp>
-      <p:sp>
-        <p:nvSpPr>
-          <p:cNvPr id="10" name="TextBox 9"/>
-          <p:cNvSpPr txBox="1"/>
-          <p:nvPr/>
-        </p:nvSpPr>
-        <p:spPr>
-          <a:xfrm>
-            <a:off x="457200" y="3246120"/>
-            <a:ext cx="3383280" cy="731520"/>
-          </a:xfrm>
-          <a:prstGeom prst="rect">
-            <a:avLst/>
-          </a:prstGeom>
-          <a:noFill/>
-        </p:spPr>
-        <p:txBody>
-          <a:bodyPr wrap="square">
-            <a:spAutoFit/>
-          </a:bodyPr>
-          <a:lstStyle/>
-          <a:p>
-            <a:pPr algn="l"/>
-            <a:r>
-              <a:rPr sz="1200" b="0" i="0">
-                <a:solidFill>
-                  <a:srgbClr val="212121"/>
-                </a:solidFill>
-                <a:latin typeface="Calibri"/>
-              </a:rPr>
-              <a:t>▸  Bolsas de residência profissional em empresas
-de alta remuneração para egressos negros</a:t>
-            </a:r>
-          </a:p>
-        </p:txBody>
-      </p:sp>
-      <p:sp>
-        <p:nvSpPr>
-          <p:cNvPr id="11" name="Rectangle 10"/>
+              <a:t>Mulher negra é a MAIS excluída: OR=0,34
+Abaixo da mulher branca (0,49) e do homem negro (0,65)</a:t>
+            </a:r>
+          </a:p>
+        </p:txBody>
+      </p:sp>
+      <p:sp>
+        <p:nvSpPr>
+          <p:cNvPr id="15" name="Rectangle 14"/>
           <p:cNvSpPr/>
           <p:nvPr/>
         </p:nvSpPr>
         <p:spPr>
           <a:xfrm>
-            <a:off x="4251959" y="1097280"/>
-            <a:ext cx="3749039" cy="5029200"/>
+            <a:off x="7315200" y="4535424"/>
+            <a:ext cx="4572000" cy="1335024"/>
           </a:xfrm>
           <a:prstGeom prst="rect">
             <a:avLst/>
@@ -21091,7 +21272,7 @@
           </a:solidFill>
           <a:ln w="19050">
             <a:solidFill>
-              <a:srgbClr val="1565C0"/>
+              <a:srgbClr val="6A008A"/>
             </a:solidFill>
           </a:ln>
         </p:spPr>
@@ -21119,20 +21300,20 @@
       </p:sp>
       <p:sp>
         <p:nvSpPr>
-          <p:cNvPr id="12" name="Rectangle 11"/>
+          <p:cNvPr id="16" name="Rectangle 15"/>
           <p:cNvSpPr/>
           <p:nvPr/>
         </p:nvSpPr>
         <p:spPr>
           <a:xfrm>
-            <a:off x="4251959" y="1097280"/>
-            <a:ext cx="3749039" cy="502920"/>
+            <a:off x="7315200" y="4535424"/>
+            <a:ext cx="4572000" cy="402336"/>
           </a:xfrm>
           <a:prstGeom prst="rect">
             <a:avLst/>
           </a:prstGeom>
           <a:solidFill>
-            <a:srgbClr val="1565C0"/>
+            <a:srgbClr val="6A008A"/>
           </a:solidFill>
           <a:ln/>
         </p:spPr>
@@ -21160,14 +21341,14 @@
       </p:sp>
       <p:sp>
         <p:nvSpPr>
-          <p:cNvPr id="13" name="TextBox 12"/>
-          <p:cNvSpPr txBox="1"/>
-          <p:nvPr/>
-        </p:nvSpPr>
-        <p:spPr>
-          <a:xfrm>
-            <a:off x="4343399" y="1143000"/>
-            <a:ext cx="3566160" cy="457200"/>
+          <p:cNvPr id="17" name="TextBox 16"/>
+          <p:cNvSpPr txBox="1"/>
+          <p:nvPr/>
+        </p:nvSpPr>
+        <p:spPr>
+          <a:xfrm>
+            <a:off x="7424927" y="4562856"/>
+            <a:ext cx="4343400" cy="384048"/>
           </a:xfrm>
           <a:prstGeom prst="rect">
             <a:avLst/>
@@ -21188,21 +21369,21 @@
                 </a:solidFill>
                 <a:latin typeface="Calibri"/>
               </a:rPr>
-              <a:t>Eixo 2 — Remuneração</a:t>
-            </a:r>
-          </a:p>
-        </p:txBody>
-      </p:sp>
-      <p:sp>
-        <p:nvSpPr>
-          <p:cNvPr id="14" name="TextBox 13"/>
-          <p:cNvSpPr txBox="1"/>
-          <p:nvPr/>
-        </p:nvSpPr>
-        <p:spPr>
-          <a:xfrm>
-            <a:off x="4434839" y="1691640"/>
-            <a:ext cx="3383280" cy="731520"/>
+              <a:t>Interação sub-aditiva</a:t>
+            </a:r>
+          </a:p>
+        </p:txBody>
+      </p:sp>
+      <p:sp>
+        <p:nvSpPr>
+          <p:cNvPr id="18" name="TextBox 17"/>
+          <p:cNvSpPr txBox="1"/>
+          <p:nvPr/>
+        </p:nvSpPr>
+        <p:spPr>
+          <a:xfrm>
+            <a:off x="7424927" y="4992624"/>
+            <a:ext cx="4343400" cy="841248"/>
           </a:xfrm>
           <a:prstGeom prst="rect">
             <a:avLst/>
@@ -21217,110 +21398,37 @@
           <a:p>
             <a:pPr algn="l"/>
             <a:r>
-              <a:rPr sz="1200" b="0" i="0">
+              <a:rPr sz="1100" b="0" i="0">
                 <a:solidFill>
                   <a:srgbClr val="212121"/>
                 </a:solidFill>
                 <a:latin typeface="Calibri"/>
               </a:rPr>
-              <a:t>▸  Transparência salarial por raça/gênero
-obrigatória (empresas &gt; 100 funcionários)</a:t>
-            </a:r>
-          </a:p>
-        </p:txBody>
-      </p:sp>
-      <p:sp>
-        <p:nvSpPr>
-          <p:cNvPr id="15" name="TextBox 14"/>
-          <p:cNvSpPr txBox="1"/>
-          <p:nvPr/>
-        </p:nvSpPr>
-        <p:spPr>
-          <a:xfrm>
-            <a:off x="4434839" y="2468880"/>
-            <a:ext cx="3383280" cy="731520"/>
-          </a:xfrm>
-          <a:prstGeom prst="rect">
-            <a:avLst/>
-          </a:prstGeom>
-          <a:noFill/>
-        </p:spPr>
-        <p:txBody>
-          <a:bodyPr wrap="square">
-            <a:spAutoFit/>
-          </a:bodyPr>
-          <a:lstStyle/>
-          <a:p>
-            <a:pPr algn="l"/>
-            <a:r>
-              <a:rPr sz="1200" b="0" i="0">
-                <a:solidFill>
-                  <a:srgbClr val="212121"/>
-                </a:solidFill>
-                <a:latin typeface="Calibri"/>
-              </a:rPr>
-              <a:t>▸  Auditoria de igual pagamento por trabalho igual
-com penalidades progressivas (gap HLM M4)</a:t>
-            </a:r>
-          </a:p>
-        </p:txBody>
-      </p:sp>
-      <p:sp>
-        <p:nvSpPr>
-          <p:cNvPr id="16" name="TextBox 15"/>
-          <p:cNvSpPr txBox="1"/>
-          <p:nvPr/>
-        </p:nvSpPr>
-        <p:spPr>
-          <a:xfrm>
-            <a:off x="4434839" y="3246120"/>
-            <a:ext cx="3383280" cy="731520"/>
-          </a:xfrm>
-          <a:prstGeom prst="rect">
-            <a:avLst/>
-          </a:prstGeom>
-          <a:noFill/>
-        </p:spPr>
-        <p:txBody>
-          <a:bodyPr wrap="square">
-            <a:spAutoFit/>
-          </a:bodyPr>
-          <a:lstStyle/>
-          <a:p>
-            <a:pPr algn="l"/>
-            <a:r>
-              <a:rPr sz="1200" b="0" i="0">
-                <a:solidFill>
-                  <a:srgbClr val="212121"/>
-                </a:solidFill>
-                <a:latin typeface="Calibri"/>
-              </a:rPr>
-              <a:t>▸  Piso salarial indexado nas categorias com
-maior gap racial residual (6,2% HLM M4)</a:t>
-            </a:r>
-          </a:p>
-        </p:txBody>
-      </p:sp>
-      <p:sp>
-        <p:nvSpPr>
-          <p:cNvPr id="17" name="Rectangle 16"/>
+              <a:t>OR=1,14 no acesso: penalidade racial um pouco menor entre mulheres — mas a negra acumula raça + teto de gênero no topo</a:t>
+            </a:r>
+          </a:p>
+        </p:txBody>
+      </p:sp>
+      <p:sp>
+        <p:nvSpPr>
+          <p:cNvPr id="19" name="Rectangle 18"/>
           <p:cNvSpPr/>
           <p:nvPr/>
         </p:nvSpPr>
         <p:spPr>
           <a:xfrm>
-            <a:off x="8229598" y="1097280"/>
-            <a:ext cx="3749039" cy="5029200"/>
+            <a:off x="274320" y="6199632"/>
+            <a:ext cx="11612880" cy="512064"/>
           </a:xfrm>
           <a:prstGeom prst="rect">
             <a:avLst/>
           </a:prstGeom>
           <a:solidFill>
-            <a:srgbClr val="F5F5F5"/>
+            <a:srgbClr val="E3F2FD"/>
           </a:solidFill>
-          <a:ln w="19050">
+          <a:ln w="10160">
             <a:solidFill>
-              <a:srgbClr val="2E7D32"/>
+              <a:srgbClr val="1F3864"/>
             </a:solidFill>
           </a:ln>
         </p:spPr>
@@ -21348,20 +21456,55 @@
       </p:sp>
       <p:sp>
         <p:nvSpPr>
-          <p:cNvPr id="18" name="Rectangle 17"/>
+          <p:cNvPr id="20" name="TextBox 19"/>
+          <p:cNvSpPr txBox="1"/>
+          <p:nvPr/>
+        </p:nvSpPr>
+        <p:spPr>
+          <a:xfrm>
+            <a:off x="457200" y="6245352"/>
+            <a:ext cx="11247120" cy="411480"/>
+          </a:xfrm>
+          <a:prstGeom prst="rect">
+            <a:avLst/>
+          </a:prstGeom>
+          <a:noFill/>
+        </p:spPr>
+        <p:txBody>
+          <a:bodyPr wrap="square">
+            <a:spAutoFit/>
+          </a:bodyPr>
+          <a:lstStyle/>
+          <a:p>
+            <a:pPr algn="l"/>
+            <a:r>
+              <a:rPr sz="1200" b="0" i="0">
+                <a:solidFill>
+                  <a:srgbClr val="1F3864"/>
+                </a:solidFill>
+                <a:latin typeface="Calibri"/>
+              </a:rPr>
+              <a:t>O teto de vidro não é racial nem sexualmente neutro: a mulher negra pode ENTRAR em ocupações qualificadas, mas é barrada de CHEGAR AO TOPO da remuneração.</a:t>
+            </a:r>
+          </a:p>
+        </p:txBody>
+      </p:sp>
+      <p:sp>
+        <p:nvSpPr>
+          <p:cNvPr id="21" name="Rectangle 20"/>
           <p:cNvSpPr/>
           <p:nvPr/>
         </p:nvSpPr>
         <p:spPr>
           <a:xfrm>
-            <a:off x="8229598" y="1097280"/>
-            <a:ext cx="3749039" cy="502920"/>
+            <a:off x="0" y="6601968"/>
+            <a:ext cx="12188952" cy="256032"/>
           </a:xfrm>
           <a:prstGeom prst="rect">
             <a:avLst/>
           </a:prstGeom>
           <a:solidFill>
-            <a:srgbClr val="2E7D32"/>
+            <a:srgbClr val="1F3864"/>
           </a:solidFill>
           <a:ln/>
         </p:spPr>
@@ -21389,226 +21532,7 @@
       </p:sp>
       <p:sp>
         <p:nvSpPr>
-          <p:cNvPr id="19" name="TextBox 18"/>
-          <p:cNvSpPr txBox="1"/>
-          <p:nvPr/>
-        </p:nvSpPr>
-        <p:spPr>
-          <a:xfrm>
-            <a:off x="8321038" y="1143000"/>
-            <a:ext cx="3566160" cy="457200"/>
-          </a:xfrm>
-          <a:prstGeom prst="rect">
-            <a:avLst/>
-          </a:prstGeom>
-          <a:noFill/>
-        </p:spPr>
-        <p:txBody>
-          <a:bodyPr wrap="square">
-            <a:spAutoFit/>
-          </a:bodyPr>
-          <a:lstStyle/>
-          <a:p>
-            <a:pPr algn="l"/>
-            <a:r>
-              <a:rPr sz="1300" b="1" i="0">
-                <a:solidFill>
-                  <a:srgbClr val="FFFFFF"/>
-                </a:solidFill>
-                <a:latin typeface="Calibri"/>
-              </a:rPr>
-              <a:t>Eixo 3 — Inclusão Produtiva</a:t>
-            </a:r>
-          </a:p>
-        </p:txBody>
-      </p:sp>
-      <p:sp>
-        <p:nvSpPr>
-          <p:cNvPr id="20" name="TextBox 19"/>
-          <p:cNvSpPr txBox="1"/>
-          <p:nvPr/>
-        </p:nvSpPr>
-        <p:spPr>
-          <a:xfrm>
-            <a:off x="8412478" y="1691640"/>
-            <a:ext cx="3383280" cy="731520"/>
-          </a:xfrm>
-          <a:prstGeom prst="rect">
-            <a:avLst/>
-          </a:prstGeom>
-          <a:noFill/>
-        </p:spPr>
-        <p:txBody>
-          <a:bodyPr wrap="square">
-            <a:spAutoFit/>
-          </a:bodyPr>
-          <a:lstStyle/>
-          <a:p>
-            <a:pPr algn="l"/>
-            <a:r>
-              <a:rPr sz="1200" b="0" i="0">
-                <a:solidFill>
-                  <a:srgbClr val="212121"/>
-                </a:solidFill>
-                <a:latin typeface="Calibri"/>
-              </a:rPr>
-              <a:t>▸  Mentoria estruturada para elevar betweenness
-de negros nas redes profissionais (SNA: =0)</a:t>
-            </a:r>
-          </a:p>
-        </p:txBody>
-      </p:sp>
-      <p:sp>
-        <p:nvSpPr>
-          <p:cNvPr id="21" name="TextBox 20"/>
-          <p:cNvSpPr txBox="1"/>
-          <p:nvPr/>
-        </p:nvSpPr>
-        <p:spPr>
-          <a:xfrm>
-            <a:off x="8412478" y="2468880"/>
-            <a:ext cx="3383280" cy="731520"/>
-          </a:xfrm>
-          <a:prstGeom prst="rect">
-            <a:avLst/>
-          </a:prstGeom>
-          <a:noFill/>
-        </p:spPr>
-        <p:txBody>
-          <a:bodyPr wrap="square">
-            <a:spAutoFit/>
-          </a:bodyPr>
-          <a:lstStyle/>
-          <a:p>
-            <a:pPr algn="l"/>
-            <a:r>
-              <a:rPr sz="1200" b="0" i="0">
-                <a:solidFill>
-                  <a:srgbClr val="212121"/>
-                </a:solidFill>
-                <a:latin typeface="Calibri"/>
-              </a:rPr>
-              <a:t>▸  30% dos cargos DAS e liderança corporativa
-para negros até 2030 (inclusão nas redes)</a:t>
-            </a:r>
-          </a:p>
-        </p:txBody>
-      </p:sp>
-      <p:sp>
-        <p:nvSpPr>
           <p:cNvPr id="22" name="TextBox 21"/>
-          <p:cNvSpPr txBox="1"/>
-          <p:nvPr/>
-        </p:nvSpPr>
-        <p:spPr>
-          <a:xfrm>
-            <a:off x="8412478" y="3246120"/>
-            <a:ext cx="3383280" cy="731520"/>
-          </a:xfrm>
-          <a:prstGeom prst="rect">
-            <a:avLst/>
-          </a:prstGeom>
-          <a:noFill/>
-        </p:spPr>
-        <p:txBody>
-          <a:bodyPr wrap="square">
-            <a:spAutoFit/>
-          </a:bodyPr>
-          <a:lstStyle/>
-          <a:p>
-            <a:pPr algn="l"/>
-            <a:r>
-              <a:rPr sz="1200" b="0" i="0">
-                <a:solidFill>
-                  <a:srgbClr val="212121"/>
-                </a:solidFill>
-                <a:latin typeface="Calibri"/>
-              </a:rPr>
-              <a:t>▸  Equalizar CBO = +127,3% renda negra
-(proxy agregado: ~74 p.p.; ver nota metodológica)</a:t>
-            </a:r>
-          </a:p>
-        </p:txBody>
-      </p:sp>
-      <p:sp>
-        <p:nvSpPr>
-          <p:cNvPr id="23" name="TextBox 22"/>
-          <p:cNvSpPr txBox="1"/>
-          <p:nvPr/>
-        </p:nvSpPr>
-        <p:spPr>
-          <a:xfrm>
-            <a:off x="274320" y="6217920"/>
-            <a:ext cx="11612880" cy="411480"/>
-          </a:xfrm>
-          <a:prstGeom prst="rect">
-            <a:avLst/>
-          </a:prstGeom>
-          <a:noFill/>
-        </p:spPr>
-        <p:txBody>
-          <a:bodyPr wrap="square">
-            <a:spAutoFit/>
-          </a:bodyPr>
-          <a:lstStyle/>
-          <a:p>
-            <a:pPr algn="ctr"/>
-            <a:r>
-              <a:rPr sz="1300" b="1" i="0">
-                <a:solidFill>
-                  <a:srgbClr val="B71C1C"/>
-                </a:solidFill>
-                <a:latin typeface="Calibri"/>
-              </a:rPr>
-              <a:t>⚠  Ao ritmo atual de convergência (~0,02 log-pontos/ano), eliminar o gap levaria mais de 100 anos.</a:t>
-            </a:r>
-          </a:p>
-        </p:txBody>
-      </p:sp>
-      <p:sp>
-        <p:nvSpPr>
-          <p:cNvPr id="24" name="Rectangle 23"/>
-          <p:cNvSpPr/>
-          <p:nvPr/>
-        </p:nvSpPr>
-        <p:spPr>
-          <a:xfrm>
-            <a:off x="0" y="6601968"/>
-            <a:ext cx="12188952" cy="256032"/>
-          </a:xfrm>
-          <a:prstGeom prst="rect">
-            <a:avLst/>
-          </a:prstGeom>
-          <a:solidFill>
-            <a:srgbClr val="1F3864"/>
-          </a:solidFill>
-          <a:ln/>
-        </p:spPr>
-        <p:style>
-          <a:lnRef idx="1">
-            <a:schemeClr val="accent1"/>
-          </a:lnRef>
-          <a:fillRef idx="3">
-            <a:schemeClr val="accent1"/>
-          </a:fillRef>
-          <a:effectRef idx="2">
-            <a:schemeClr val="accent1"/>
-          </a:effectRef>
-          <a:fontRef idx="minor">
-            <a:schemeClr val="lt1"/>
-          </a:fontRef>
-        </p:style>
-        <p:txBody>
-          <a:bodyPr rtlCol="0" anchor="ctr"/>
-          <a:lstStyle/>
-          <a:p>
-            <a:pPr algn="ctr"/>
-          </a:p>
-        </p:txBody>
-      </p:sp>
-      <p:sp>
-        <p:nvSpPr>
-          <p:cNvPr id="25" name="TextBox 24"/>
           <p:cNvSpPr txBox="1"/>
           <p:nvPr/>
         </p:nvSpPr>
@@ -21643,7 +21567,7 @@
       </p:sp>
       <p:sp>
         <p:nvSpPr>
-          <p:cNvPr id="26" name="TextBox 25"/>
+          <p:cNvPr id="23" name="TextBox 22"/>
           <p:cNvSpPr txBox="1"/>
           <p:nvPr/>
         </p:nvSpPr>
@@ -21671,7 +21595,7 @@
                 </a:solidFill>
                 <a:latin typeface="Calibri"/>
               </a:rPr>
-              <a:t>27/28</a:t>
+              <a:t>27/29</a:t>
             </a:r>
           </a:p>
         </p:txBody>
@@ -21765,7 +21689,7 @@
                 </a:solidFill>
                 <a:latin typeface="Calibri"/>
               </a:rPr>
-              <a:t>27. Limitações e Agenda Futura</a:t>
+              <a:t>27. Implicações de Política</a:t>
             </a:r>
           </a:p>
         </p:txBody>
@@ -21800,370 +21724,33 @@
                 </a:solidFill>
                 <a:latin typeface="Calibri"/>
               </a:rPr>
-              <a:t>Honestidade acadêmica: o que este trabalho não faz e por quê</a:t>
-            </a:r>
-          </a:p>
-        </p:txBody>
-      </p:sp>
-      <p:sp>
-        <p:nvSpPr>
-          <p:cNvPr id="5" name="TextBox 4"/>
-          <p:cNvSpPr txBox="1"/>
-          <p:nvPr/>
-        </p:nvSpPr>
-        <p:spPr>
-          <a:xfrm>
-            <a:off x="365760" y="1143000"/>
-            <a:ext cx="5486400" cy="365760"/>
-          </a:xfrm>
-          <a:prstGeom prst="rect">
-            <a:avLst/>
-          </a:prstGeom>
-          <a:noFill/>
-        </p:spPr>
-        <p:txBody>
-          <a:bodyPr wrap="square">
-            <a:spAutoFit/>
-          </a:bodyPr>
-          <a:lstStyle/>
-          <a:p>
-            <a:pPr algn="l"/>
-            <a:r>
-              <a:rPr sz="1600" b="1" i="0">
-                <a:solidFill>
-                  <a:srgbClr val="B71C1C"/>
-                </a:solidFill>
-                <a:latin typeface="Calibri"/>
-              </a:rPr>
-              <a:t>Limitações</a:t>
-            </a:r>
-          </a:p>
-        </p:txBody>
-      </p:sp>
-      <p:sp>
-        <p:nvSpPr>
-          <p:cNvPr id="6" name="TextBox 5"/>
-          <p:cNvSpPr txBox="1"/>
-          <p:nvPr/>
-        </p:nvSpPr>
-        <p:spPr>
-          <a:xfrm>
-            <a:off x="365760" y="1600200"/>
-            <a:ext cx="5669280" cy="3474720"/>
-          </a:xfrm>
-          <a:prstGeom prst="rect">
-            <a:avLst/>
-          </a:prstGeom>
-          <a:noFill/>
-        </p:spPr>
-        <p:txBody>
-          <a:bodyPr wrap="square">
-            <a:spAutoFit/>
-          </a:bodyPr>
-          <a:lstStyle/>
-          <a:p>
-            <a:pPr>
-              <a:spcAft>
-                <a:spcPts val="400"/>
-              </a:spcAft>
-            </a:pPr>
-            <a:r>
-              <a:rPr sz="1300" b="1">
-                <a:solidFill>
-                  <a:srgbClr val="B71C1C"/>
-                </a:solidFill>
-                <a:latin typeface="Calibri"/>
-              </a:rPr>
-              <a:t>▸  </a:t>
-            </a:r>
-            <a:r>
-              <a:rPr sz="1300">
-                <a:solidFill>
-                  <a:srgbClr val="212121"/>
-                </a:solidFill>
-                <a:latin typeface="Calibri"/>
-              </a:rPr>
-              <a:t>PNAD não permite experimentos causais — coeficientes são associações condicionais, não efeitos causais no sentido de Rubin/Pearl</a:t>
-            </a:r>
-          </a:p>
-          <a:p>
-            <a:pPr>
-              <a:spcAft>
-                <a:spcPts val="400"/>
-              </a:spcAft>
-            </a:pPr>
-            <a:r>
-              <a:rPr sz="1300" b="1">
-                <a:solidFill>
-                  <a:srgbClr val="B71C1C"/>
-                </a:solidFill>
-                <a:latin typeface="Calibri"/>
-              </a:rPr>
-              <a:t>▸  </a:t>
-            </a:r>
-            <a:r>
-              <a:rPr sz="1300">
-                <a:solidFill>
-                  <a:srgbClr val="212121"/>
-                </a:solidFill>
-                <a:latin typeface="Calibri"/>
-              </a:rPr>
-              <a:t>UPA como proxy de bairro: unidade de amostragem ≠ bairro administrativo</a:t>
-            </a:r>
-          </a:p>
-          <a:p>
-            <a:pPr>
-              <a:spcAft>
-                <a:spcPts val="400"/>
-              </a:spcAft>
-            </a:pPr>
-            <a:r>
-              <a:rPr sz="1300" b="1">
-                <a:solidFill>
-                  <a:srgbClr val="B71C1C"/>
-                </a:solidFill>
-                <a:latin typeface="Calibri"/>
-              </a:rPr>
-              <a:t>▸  </a:t>
-            </a:r>
-            <a:r>
-              <a:rPr sz="1300">
-                <a:solidFill>
-                  <a:srgbClr val="212121"/>
-                </a:solidFill>
-                <a:latin typeface="Calibri"/>
-              </a:rPr>
-              <a:t>GLMM logístico estimado na PEA completa via lme4::glmer (nAGQ=0, bobyqa, n=7,7M, 40,9k UPAs); random slope de negro no GLMM não estimado por custo — porém o random slope foi estimado no HLM de salário (base da PO regionalizada por UF)</a:t>
-            </a:r>
-          </a:p>
-          <a:p>
-            <a:pPr>
-              <a:spcAft>
-                <a:spcPts val="400"/>
-              </a:spcAft>
-            </a:pPr>
-            <a:r>
-              <a:rPr sz="1300" b="1">
-                <a:solidFill>
-                  <a:srgbClr val="B71C1C"/>
-                </a:solidFill>
-                <a:latin typeface="Calibri"/>
-              </a:rPr>
-              <a:t>▸  </a:t>
-            </a:r>
-            <a:r>
-              <a:rPr sz="1300">
-                <a:solidFill>
-                  <a:srgbClr val="212121"/>
-                </a:solidFill>
-                <a:latin typeface="Calibri"/>
-              </a:rPr>
-              <a:t>CBO auto-declarado pode ter viés de classificação por raça (deflation de ocupação)</a:t>
-            </a:r>
-          </a:p>
-        </p:txBody>
-      </p:sp>
-      <p:sp>
-        <p:nvSpPr>
-          <p:cNvPr id="7" name="TextBox 6"/>
-          <p:cNvSpPr txBox="1"/>
-          <p:nvPr/>
-        </p:nvSpPr>
-        <p:spPr>
-          <a:xfrm>
-            <a:off x="6400800" y="1143000"/>
-            <a:ext cx="5486400" cy="365760"/>
-          </a:xfrm>
-          <a:prstGeom prst="rect">
-            <a:avLst/>
-          </a:prstGeom>
-          <a:noFill/>
-        </p:spPr>
-        <p:txBody>
-          <a:bodyPr wrap="square">
-            <a:spAutoFit/>
-          </a:bodyPr>
-          <a:lstStyle/>
-          <a:p>
-            <a:pPr algn="l"/>
-            <a:r>
-              <a:rPr sz="1600" b="1" i="0">
-                <a:solidFill>
-                  <a:srgbClr val="1565C0"/>
-                </a:solidFill>
-                <a:latin typeface="Calibri"/>
-              </a:rPr>
-              <a:t>Agenda Futura</a:t>
-            </a:r>
-          </a:p>
-        </p:txBody>
-      </p:sp>
-      <p:sp>
-        <p:nvSpPr>
-          <p:cNvPr id="8" name="TextBox 7"/>
-          <p:cNvSpPr txBox="1"/>
-          <p:nvPr/>
-        </p:nvSpPr>
-        <p:spPr>
-          <a:xfrm>
-            <a:off x="6400800" y="1600200"/>
-            <a:ext cx="5669280" cy="3474720"/>
-          </a:xfrm>
-          <a:prstGeom prst="rect">
-            <a:avLst/>
-          </a:prstGeom>
-          <a:noFill/>
-        </p:spPr>
-        <p:txBody>
-          <a:bodyPr wrap="square">
-            <a:spAutoFit/>
-          </a:bodyPr>
-          <a:lstStyle/>
-          <a:p>
-            <a:pPr>
-              <a:spcAft>
-                <a:spcPts val="400"/>
-              </a:spcAft>
-            </a:pPr>
-            <a:r>
-              <a:rPr sz="1300" b="1">
-                <a:solidFill>
-                  <a:srgbClr val="1565C0"/>
-                </a:solidFill>
-                <a:latin typeface="Calibri"/>
-              </a:rPr>
-              <a:t>▸  </a:t>
-            </a:r>
-            <a:r>
-              <a:rPr sz="1300">
-                <a:solidFill>
-                  <a:srgbClr val="212121"/>
-                </a:solidFill>
-                <a:latin typeface="Calibri"/>
-              </a:rPr>
-              <a:t>Análise de variáveis instrumentais (IV) para identificação causal — distância à escola técnica como instrumento</a:t>
-            </a:r>
-          </a:p>
-          <a:p>
-            <a:pPr>
-              <a:spcAft>
-                <a:spcPts val="400"/>
-              </a:spcAft>
-            </a:pPr>
-            <a:r>
-              <a:rPr sz="1300" b="1">
-                <a:solidFill>
-                  <a:srgbClr val="1565C0"/>
-                </a:solidFill>
-                <a:latin typeface="Calibri"/>
-              </a:rPr>
-              <a:t>▸  </a:t>
-            </a:r>
-            <a:r>
-              <a:rPr sz="1300">
-                <a:solidFill>
-                  <a:srgbClr val="212121"/>
-                </a:solidFill>
-                <a:latin typeface="Calibri"/>
-              </a:rPr>
-              <a:t>RAIS linkada à PNAD para rastrear trajetórias de mobilidade intraempresa</a:t>
-            </a:r>
-          </a:p>
-          <a:p>
-            <a:pPr>
-              <a:spcAft>
-                <a:spcPts val="400"/>
-              </a:spcAft>
-            </a:pPr>
-            <a:r>
-              <a:rPr sz="1300" b="1">
-                <a:solidFill>
-                  <a:srgbClr val="1565C0"/>
-                </a:solidFill>
-                <a:latin typeface="Calibri"/>
-              </a:rPr>
-              <a:t>▸  </a:t>
-            </a:r>
-            <a:r>
-              <a:rPr sz="1300">
-                <a:solidFill>
-                  <a:srgbClr val="212121"/>
-                </a:solidFill>
-                <a:latin typeface="Calibri"/>
-              </a:rPr>
-              <a:t>Análise de mediação formal (path analysis) raça → ocupação → renda</a:t>
-            </a:r>
-          </a:p>
-          <a:p>
-            <a:pPr>
-              <a:spcAft>
-                <a:spcPts val="400"/>
-              </a:spcAft>
-            </a:pPr>
-            <a:r>
-              <a:rPr sz="1300" b="1">
-                <a:solidFill>
-                  <a:srgbClr val="1565C0"/>
-                </a:solidFill>
-                <a:latin typeface="Calibri"/>
-              </a:rPr>
-              <a:t>▸  </a:t>
-            </a:r>
-            <a:r>
-              <a:rPr sz="1300">
-                <a:solidFill>
-                  <a:srgbClr val="212121"/>
-                </a:solidFill>
-                <a:latin typeface="Calibri"/>
-              </a:rPr>
-              <a:t>Extensão ao setor público por UF — heterogeneidade do glass ceiling entre estados</a:t>
-            </a:r>
-          </a:p>
-          <a:p>
-            <a:pPr>
-              <a:spcAft>
-                <a:spcPts val="400"/>
-              </a:spcAft>
-            </a:pPr>
-            <a:r>
-              <a:rPr sz="1300" b="1">
-                <a:solidFill>
-                  <a:srgbClr val="1565C0"/>
-                </a:solidFill>
-                <a:latin typeface="Calibri"/>
-              </a:rPr>
-              <a:t>▸  </a:t>
-            </a:r>
-            <a:r>
-              <a:rPr sz="1300">
-                <a:solidFill>
-                  <a:srgbClr val="212121"/>
-                </a:solidFill>
-                <a:latin typeface="Calibri"/>
-              </a:rPr>
-              <a:t>Modelo longitudinal com painéis rotativos da PNAD (2T seguidos) para efeitos fixos de indivíduo</a:t>
-            </a:r>
-          </a:p>
-        </p:txBody>
-      </p:sp>
-      <p:sp>
-        <p:nvSpPr>
-          <p:cNvPr id="9" name="Rectangle 8"/>
+              <a:t>Três eixos simultâneos — ações isoladas são insuficientes para romper a armadilha estrutural</a:t>
+            </a:r>
+          </a:p>
+        </p:txBody>
+      </p:sp>
+      <p:sp>
+        <p:nvSpPr>
+          <p:cNvPr id="5" name="Rectangle 4"/>
           <p:cNvSpPr/>
           <p:nvPr/>
         </p:nvSpPr>
         <p:spPr>
           <a:xfrm>
-            <a:off x="0" y="6601968"/>
-            <a:ext cx="12188952" cy="256032"/>
+            <a:off x="274320" y="1097280"/>
+            <a:ext cx="3749039" cy="5029200"/>
           </a:xfrm>
           <a:prstGeom prst="rect">
             <a:avLst/>
           </a:prstGeom>
           <a:solidFill>
-            <a:srgbClr val="1F3864"/>
+            <a:srgbClr val="F5F5F5"/>
           </a:solidFill>
-          <a:ln/>
+          <a:ln w="19050">
+            <a:solidFill>
+              <a:srgbClr val="B71C1C"/>
+            </a:solidFill>
+          </a:ln>
         </p:spPr>
         <p:style>
           <a:lnRef idx="1">
@@ -22189,7 +21776,725 @@
       </p:sp>
       <p:sp>
         <p:nvSpPr>
+          <p:cNvPr id="6" name="Rectangle 5"/>
+          <p:cNvSpPr/>
+          <p:nvPr/>
+        </p:nvSpPr>
+        <p:spPr>
+          <a:xfrm>
+            <a:off x="274320" y="1097280"/>
+            <a:ext cx="3749039" cy="502920"/>
+          </a:xfrm>
+          <a:prstGeom prst="rect">
+            <a:avLst/>
+          </a:prstGeom>
+          <a:solidFill>
+            <a:srgbClr val="B71C1C"/>
+          </a:solidFill>
+          <a:ln/>
+        </p:spPr>
+        <p:style>
+          <a:lnRef idx="1">
+            <a:schemeClr val="accent1"/>
+          </a:lnRef>
+          <a:fillRef idx="3">
+            <a:schemeClr val="accent1"/>
+          </a:fillRef>
+          <a:effectRef idx="2">
+            <a:schemeClr val="accent1"/>
+          </a:effectRef>
+          <a:fontRef idx="minor">
+            <a:schemeClr val="lt1"/>
+          </a:fontRef>
+        </p:style>
+        <p:txBody>
+          <a:bodyPr rtlCol="0" anchor="ctr"/>
+          <a:lstStyle/>
+          <a:p>
+            <a:pPr algn="ctr"/>
+          </a:p>
+        </p:txBody>
+      </p:sp>
+      <p:sp>
+        <p:nvSpPr>
+          <p:cNvPr id="7" name="TextBox 6"/>
+          <p:cNvSpPr txBox="1"/>
+          <p:nvPr/>
+        </p:nvSpPr>
+        <p:spPr>
+          <a:xfrm>
+            <a:off x="365760" y="1143000"/>
+            <a:ext cx="3566160" cy="457200"/>
+          </a:xfrm>
+          <a:prstGeom prst="rect">
+            <a:avLst/>
+          </a:prstGeom>
+          <a:noFill/>
+        </p:spPr>
+        <p:txBody>
+          <a:bodyPr wrap="square">
+            <a:spAutoFit/>
+          </a:bodyPr>
+          <a:lstStyle/>
+          <a:p>
+            <a:pPr algn="l"/>
+            <a:r>
+              <a:rPr sz="1300" b="1" i="0">
+                <a:solidFill>
+                  <a:srgbClr val="FFFFFF"/>
+                </a:solidFill>
+                <a:latin typeface="Calibri"/>
+              </a:rPr>
+              <a:t>Eixo 1 — Acesso</a:t>
+            </a:r>
+          </a:p>
+        </p:txBody>
+      </p:sp>
+      <p:sp>
+        <p:nvSpPr>
+          <p:cNvPr id="8" name="TextBox 7"/>
+          <p:cNvSpPr txBox="1"/>
+          <p:nvPr/>
+        </p:nvSpPr>
+        <p:spPr>
+          <a:xfrm>
+            <a:off x="457200" y="1691640"/>
+            <a:ext cx="3383280" cy="731520"/>
+          </a:xfrm>
+          <a:prstGeom prst="rect">
+            <a:avLst/>
+          </a:prstGeom>
+          <a:noFill/>
+        </p:spPr>
+        <p:txBody>
+          <a:bodyPr wrap="square">
+            <a:spAutoFit/>
+          </a:bodyPr>
+          <a:lstStyle/>
+          <a:p>
+            <a:pPr algn="l"/>
+            <a:r>
+              <a:rPr sz="1200" b="0" i="0">
+                <a:solidFill>
+                  <a:srgbClr val="212121"/>
+                </a:solidFill>
+                <a:latin typeface="Calibri"/>
+              </a:rPr>
+              <a:t>▸  Cotas de acesso CBO Dirigente/Profissional:
+meta IR ≥ 0,80 até 2030</a:t>
+            </a:r>
+          </a:p>
+        </p:txBody>
+      </p:sp>
+      <p:sp>
+        <p:nvSpPr>
+          <p:cNvPr id="9" name="TextBox 8"/>
+          <p:cNvSpPr txBox="1"/>
+          <p:nvPr/>
+        </p:nvSpPr>
+        <p:spPr>
+          <a:xfrm>
+            <a:off x="457200" y="2468880"/>
+            <a:ext cx="3383280" cy="731520"/>
+          </a:xfrm>
+          <a:prstGeom prst="rect">
+            <a:avLst/>
+          </a:prstGeom>
+          <a:noFill/>
+        </p:spPr>
+        <p:txBody>
+          <a:bodyPr wrap="square">
+            <a:spAutoFit/>
+          </a:bodyPr>
+          <a:lstStyle/>
+          <a:p>
+            <a:pPr algn="l"/>
+            <a:r>
+              <a:rPr sz="1200" b="0" i="0">
+                <a:solidFill>
+                  <a:srgbClr val="212121"/>
+                </a:solidFill>
+                <a:latin typeface="Calibri"/>
+              </a:rPr>
+              <a:t>▸  PRONATEC c/ recorte racial e subsídio de
+transporte para trabalhadores de UPAs pobres</a:t>
+            </a:r>
+          </a:p>
+        </p:txBody>
+      </p:sp>
+      <p:sp>
+        <p:nvSpPr>
           <p:cNvPr id="10" name="TextBox 9"/>
+          <p:cNvSpPr txBox="1"/>
+          <p:nvPr/>
+        </p:nvSpPr>
+        <p:spPr>
+          <a:xfrm>
+            <a:off x="457200" y="3246120"/>
+            <a:ext cx="3383280" cy="731520"/>
+          </a:xfrm>
+          <a:prstGeom prst="rect">
+            <a:avLst/>
+          </a:prstGeom>
+          <a:noFill/>
+        </p:spPr>
+        <p:txBody>
+          <a:bodyPr wrap="square">
+            <a:spAutoFit/>
+          </a:bodyPr>
+          <a:lstStyle/>
+          <a:p>
+            <a:pPr algn="l"/>
+            <a:r>
+              <a:rPr sz="1200" b="0" i="0">
+                <a:solidFill>
+                  <a:srgbClr val="212121"/>
+                </a:solidFill>
+                <a:latin typeface="Calibri"/>
+              </a:rPr>
+              <a:t>▸  Bolsas de residência profissional em empresas
+de alta remuneração para egressos negros</a:t>
+            </a:r>
+          </a:p>
+        </p:txBody>
+      </p:sp>
+      <p:sp>
+        <p:nvSpPr>
+          <p:cNvPr id="11" name="Rectangle 10"/>
+          <p:cNvSpPr/>
+          <p:nvPr/>
+        </p:nvSpPr>
+        <p:spPr>
+          <a:xfrm>
+            <a:off x="4251959" y="1097280"/>
+            <a:ext cx="3749039" cy="5029200"/>
+          </a:xfrm>
+          <a:prstGeom prst="rect">
+            <a:avLst/>
+          </a:prstGeom>
+          <a:solidFill>
+            <a:srgbClr val="F5F5F5"/>
+          </a:solidFill>
+          <a:ln w="19050">
+            <a:solidFill>
+              <a:srgbClr val="1565C0"/>
+            </a:solidFill>
+          </a:ln>
+        </p:spPr>
+        <p:style>
+          <a:lnRef idx="1">
+            <a:schemeClr val="accent1"/>
+          </a:lnRef>
+          <a:fillRef idx="3">
+            <a:schemeClr val="accent1"/>
+          </a:fillRef>
+          <a:effectRef idx="2">
+            <a:schemeClr val="accent1"/>
+          </a:effectRef>
+          <a:fontRef idx="minor">
+            <a:schemeClr val="lt1"/>
+          </a:fontRef>
+        </p:style>
+        <p:txBody>
+          <a:bodyPr rtlCol="0" anchor="ctr"/>
+          <a:lstStyle/>
+          <a:p>
+            <a:pPr algn="ctr"/>
+          </a:p>
+        </p:txBody>
+      </p:sp>
+      <p:sp>
+        <p:nvSpPr>
+          <p:cNvPr id="12" name="Rectangle 11"/>
+          <p:cNvSpPr/>
+          <p:nvPr/>
+        </p:nvSpPr>
+        <p:spPr>
+          <a:xfrm>
+            <a:off x="4251959" y="1097280"/>
+            <a:ext cx="3749039" cy="502920"/>
+          </a:xfrm>
+          <a:prstGeom prst="rect">
+            <a:avLst/>
+          </a:prstGeom>
+          <a:solidFill>
+            <a:srgbClr val="1565C0"/>
+          </a:solidFill>
+          <a:ln/>
+        </p:spPr>
+        <p:style>
+          <a:lnRef idx="1">
+            <a:schemeClr val="accent1"/>
+          </a:lnRef>
+          <a:fillRef idx="3">
+            <a:schemeClr val="accent1"/>
+          </a:fillRef>
+          <a:effectRef idx="2">
+            <a:schemeClr val="accent1"/>
+          </a:effectRef>
+          <a:fontRef idx="minor">
+            <a:schemeClr val="lt1"/>
+          </a:fontRef>
+        </p:style>
+        <p:txBody>
+          <a:bodyPr rtlCol="0" anchor="ctr"/>
+          <a:lstStyle/>
+          <a:p>
+            <a:pPr algn="ctr"/>
+          </a:p>
+        </p:txBody>
+      </p:sp>
+      <p:sp>
+        <p:nvSpPr>
+          <p:cNvPr id="13" name="TextBox 12"/>
+          <p:cNvSpPr txBox="1"/>
+          <p:nvPr/>
+        </p:nvSpPr>
+        <p:spPr>
+          <a:xfrm>
+            <a:off x="4343399" y="1143000"/>
+            <a:ext cx="3566160" cy="457200"/>
+          </a:xfrm>
+          <a:prstGeom prst="rect">
+            <a:avLst/>
+          </a:prstGeom>
+          <a:noFill/>
+        </p:spPr>
+        <p:txBody>
+          <a:bodyPr wrap="square">
+            <a:spAutoFit/>
+          </a:bodyPr>
+          <a:lstStyle/>
+          <a:p>
+            <a:pPr algn="l"/>
+            <a:r>
+              <a:rPr sz="1300" b="1" i="0">
+                <a:solidFill>
+                  <a:srgbClr val="FFFFFF"/>
+                </a:solidFill>
+                <a:latin typeface="Calibri"/>
+              </a:rPr>
+              <a:t>Eixo 2 — Remuneração</a:t>
+            </a:r>
+          </a:p>
+        </p:txBody>
+      </p:sp>
+      <p:sp>
+        <p:nvSpPr>
+          <p:cNvPr id="14" name="TextBox 13"/>
+          <p:cNvSpPr txBox="1"/>
+          <p:nvPr/>
+        </p:nvSpPr>
+        <p:spPr>
+          <a:xfrm>
+            <a:off x="4434839" y="1691640"/>
+            <a:ext cx="3383280" cy="731520"/>
+          </a:xfrm>
+          <a:prstGeom prst="rect">
+            <a:avLst/>
+          </a:prstGeom>
+          <a:noFill/>
+        </p:spPr>
+        <p:txBody>
+          <a:bodyPr wrap="square">
+            <a:spAutoFit/>
+          </a:bodyPr>
+          <a:lstStyle/>
+          <a:p>
+            <a:pPr algn="l"/>
+            <a:r>
+              <a:rPr sz="1200" b="0" i="0">
+                <a:solidFill>
+                  <a:srgbClr val="212121"/>
+                </a:solidFill>
+                <a:latin typeface="Calibri"/>
+              </a:rPr>
+              <a:t>▸  Transparência salarial por raça/gênero
+obrigatória (empresas &gt; 100 funcionários)</a:t>
+            </a:r>
+          </a:p>
+        </p:txBody>
+      </p:sp>
+      <p:sp>
+        <p:nvSpPr>
+          <p:cNvPr id="15" name="TextBox 14"/>
+          <p:cNvSpPr txBox="1"/>
+          <p:nvPr/>
+        </p:nvSpPr>
+        <p:spPr>
+          <a:xfrm>
+            <a:off x="4434839" y="2468880"/>
+            <a:ext cx="3383280" cy="731520"/>
+          </a:xfrm>
+          <a:prstGeom prst="rect">
+            <a:avLst/>
+          </a:prstGeom>
+          <a:noFill/>
+        </p:spPr>
+        <p:txBody>
+          <a:bodyPr wrap="square">
+            <a:spAutoFit/>
+          </a:bodyPr>
+          <a:lstStyle/>
+          <a:p>
+            <a:pPr algn="l"/>
+            <a:r>
+              <a:rPr sz="1200" b="0" i="0">
+                <a:solidFill>
+                  <a:srgbClr val="212121"/>
+                </a:solidFill>
+                <a:latin typeface="Calibri"/>
+              </a:rPr>
+              <a:t>▸  Auditoria de igual pagamento por trabalho igual
+com penalidades progressivas (gap HLM M4)</a:t>
+            </a:r>
+          </a:p>
+        </p:txBody>
+      </p:sp>
+      <p:sp>
+        <p:nvSpPr>
+          <p:cNvPr id="16" name="TextBox 15"/>
+          <p:cNvSpPr txBox="1"/>
+          <p:nvPr/>
+        </p:nvSpPr>
+        <p:spPr>
+          <a:xfrm>
+            <a:off x="4434839" y="3246120"/>
+            <a:ext cx="3383280" cy="731520"/>
+          </a:xfrm>
+          <a:prstGeom prst="rect">
+            <a:avLst/>
+          </a:prstGeom>
+          <a:noFill/>
+        </p:spPr>
+        <p:txBody>
+          <a:bodyPr wrap="square">
+            <a:spAutoFit/>
+          </a:bodyPr>
+          <a:lstStyle/>
+          <a:p>
+            <a:pPr algn="l"/>
+            <a:r>
+              <a:rPr sz="1200" b="0" i="0">
+                <a:solidFill>
+                  <a:srgbClr val="212121"/>
+                </a:solidFill>
+                <a:latin typeface="Calibri"/>
+              </a:rPr>
+              <a:t>▸  Piso salarial indexado nas categorias com
+maior gap racial residual (6,2% HLM M4)</a:t>
+            </a:r>
+          </a:p>
+        </p:txBody>
+      </p:sp>
+      <p:sp>
+        <p:nvSpPr>
+          <p:cNvPr id="17" name="Rectangle 16"/>
+          <p:cNvSpPr/>
+          <p:nvPr/>
+        </p:nvSpPr>
+        <p:spPr>
+          <a:xfrm>
+            <a:off x="8229598" y="1097280"/>
+            <a:ext cx="3749039" cy="5029200"/>
+          </a:xfrm>
+          <a:prstGeom prst="rect">
+            <a:avLst/>
+          </a:prstGeom>
+          <a:solidFill>
+            <a:srgbClr val="F5F5F5"/>
+          </a:solidFill>
+          <a:ln w="19050">
+            <a:solidFill>
+              <a:srgbClr val="2E7D32"/>
+            </a:solidFill>
+          </a:ln>
+        </p:spPr>
+        <p:style>
+          <a:lnRef idx="1">
+            <a:schemeClr val="accent1"/>
+          </a:lnRef>
+          <a:fillRef idx="3">
+            <a:schemeClr val="accent1"/>
+          </a:fillRef>
+          <a:effectRef idx="2">
+            <a:schemeClr val="accent1"/>
+          </a:effectRef>
+          <a:fontRef idx="minor">
+            <a:schemeClr val="lt1"/>
+          </a:fontRef>
+        </p:style>
+        <p:txBody>
+          <a:bodyPr rtlCol="0" anchor="ctr"/>
+          <a:lstStyle/>
+          <a:p>
+            <a:pPr algn="ctr"/>
+          </a:p>
+        </p:txBody>
+      </p:sp>
+      <p:sp>
+        <p:nvSpPr>
+          <p:cNvPr id="18" name="Rectangle 17"/>
+          <p:cNvSpPr/>
+          <p:nvPr/>
+        </p:nvSpPr>
+        <p:spPr>
+          <a:xfrm>
+            <a:off x="8229598" y="1097280"/>
+            <a:ext cx="3749039" cy="502920"/>
+          </a:xfrm>
+          <a:prstGeom prst="rect">
+            <a:avLst/>
+          </a:prstGeom>
+          <a:solidFill>
+            <a:srgbClr val="2E7D32"/>
+          </a:solidFill>
+          <a:ln/>
+        </p:spPr>
+        <p:style>
+          <a:lnRef idx="1">
+            <a:schemeClr val="accent1"/>
+          </a:lnRef>
+          <a:fillRef idx="3">
+            <a:schemeClr val="accent1"/>
+          </a:fillRef>
+          <a:effectRef idx="2">
+            <a:schemeClr val="accent1"/>
+          </a:effectRef>
+          <a:fontRef idx="minor">
+            <a:schemeClr val="lt1"/>
+          </a:fontRef>
+        </p:style>
+        <p:txBody>
+          <a:bodyPr rtlCol="0" anchor="ctr"/>
+          <a:lstStyle/>
+          <a:p>
+            <a:pPr algn="ctr"/>
+          </a:p>
+        </p:txBody>
+      </p:sp>
+      <p:sp>
+        <p:nvSpPr>
+          <p:cNvPr id="19" name="TextBox 18"/>
+          <p:cNvSpPr txBox="1"/>
+          <p:nvPr/>
+        </p:nvSpPr>
+        <p:spPr>
+          <a:xfrm>
+            <a:off x="8321038" y="1143000"/>
+            <a:ext cx="3566160" cy="457200"/>
+          </a:xfrm>
+          <a:prstGeom prst="rect">
+            <a:avLst/>
+          </a:prstGeom>
+          <a:noFill/>
+        </p:spPr>
+        <p:txBody>
+          <a:bodyPr wrap="square">
+            <a:spAutoFit/>
+          </a:bodyPr>
+          <a:lstStyle/>
+          <a:p>
+            <a:pPr algn="l"/>
+            <a:r>
+              <a:rPr sz="1300" b="1" i="0">
+                <a:solidFill>
+                  <a:srgbClr val="FFFFFF"/>
+                </a:solidFill>
+                <a:latin typeface="Calibri"/>
+              </a:rPr>
+              <a:t>Eixo 3 — Inclusão Produtiva</a:t>
+            </a:r>
+          </a:p>
+        </p:txBody>
+      </p:sp>
+      <p:sp>
+        <p:nvSpPr>
+          <p:cNvPr id="20" name="TextBox 19"/>
+          <p:cNvSpPr txBox="1"/>
+          <p:nvPr/>
+        </p:nvSpPr>
+        <p:spPr>
+          <a:xfrm>
+            <a:off x="8412478" y="1691640"/>
+            <a:ext cx="3383280" cy="731520"/>
+          </a:xfrm>
+          <a:prstGeom prst="rect">
+            <a:avLst/>
+          </a:prstGeom>
+          <a:noFill/>
+        </p:spPr>
+        <p:txBody>
+          <a:bodyPr wrap="square">
+            <a:spAutoFit/>
+          </a:bodyPr>
+          <a:lstStyle/>
+          <a:p>
+            <a:pPr algn="l"/>
+            <a:r>
+              <a:rPr sz="1200" b="0" i="0">
+                <a:solidFill>
+                  <a:srgbClr val="212121"/>
+                </a:solidFill>
+                <a:latin typeface="Calibri"/>
+              </a:rPr>
+              <a:t>▸  Mentoria estruturada para elevar betweenness
+de negros nas redes profissionais (SNA: =0)</a:t>
+            </a:r>
+          </a:p>
+        </p:txBody>
+      </p:sp>
+      <p:sp>
+        <p:nvSpPr>
+          <p:cNvPr id="21" name="TextBox 20"/>
+          <p:cNvSpPr txBox="1"/>
+          <p:nvPr/>
+        </p:nvSpPr>
+        <p:spPr>
+          <a:xfrm>
+            <a:off x="8412478" y="2468880"/>
+            <a:ext cx="3383280" cy="731520"/>
+          </a:xfrm>
+          <a:prstGeom prst="rect">
+            <a:avLst/>
+          </a:prstGeom>
+          <a:noFill/>
+        </p:spPr>
+        <p:txBody>
+          <a:bodyPr wrap="square">
+            <a:spAutoFit/>
+          </a:bodyPr>
+          <a:lstStyle/>
+          <a:p>
+            <a:pPr algn="l"/>
+            <a:r>
+              <a:rPr sz="1200" b="0" i="0">
+                <a:solidFill>
+                  <a:srgbClr val="212121"/>
+                </a:solidFill>
+                <a:latin typeface="Calibri"/>
+              </a:rPr>
+              <a:t>▸  30% dos cargos DAS e liderança corporativa
+para negros até 2030 (inclusão nas redes)</a:t>
+            </a:r>
+          </a:p>
+        </p:txBody>
+      </p:sp>
+      <p:sp>
+        <p:nvSpPr>
+          <p:cNvPr id="22" name="TextBox 21"/>
+          <p:cNvSpPr txBox="1"/>
+          <p:nvPr/>
+        </p:nvSpPr>
+        <p:spPr>
+          <a:xfrm>
+            <a:off x="8412478" y="3246120"/>
+            <a:ext cx="3383280" cy="731520"/>
+          </a:xfrm>
+          <a:prstGeom prst="rect">
+            <a:avLst/>
+          </a:prstGeom>
+          <a:noFill/>
+        </p:spPr>
+        <p:txBody>
+          <a:bodyPr wrap="square">
+            <a:spAutoFit/>
+          </a:bodyPr>
+          <a:lstStyle/>
+          <a:p>
+            <a:pPr algn="l"/>
+            <a:r>
+              <a:rPr sz="1200" b="0" i="0">
+                <a:solidFill>
+                  <a:srgbClr val="212121"/>
+                </a:solidFill>
+                <a:latin typeface="Calibri"/>
+              </a:rPr>
+              <a:t>▸  Equalizar CBO = +127,3% renda negra
+(proxy agregado: ~74 p.p.; ver nota metodológica)</a:t>
+            </a:r>
+          </a:p>
+        </p:txBody>
+      </p:sp>
+      <p:sp>
+        <p:nvSpPr>
+          <p:cNvPr id="23" name="TextBox 22"/>
+          <p:cNvSpPr txBox="1"/>
+          <p:nvPr/>
+        </p:nvSpPr>
+        <p:spPr>
+          <a:xfrm>
+            <a:off x="274320" y="6217920"/>
+            <a:ext cx="11612880" cy="411480"/>
+          </a:xfrm>
+          <a:prstGeom prst="rect">
+            <a:avLst/>
+          </a:prstGeom>
+          <a:noFill/>
+        </p:spPr>
+        <p:txBody>
+          <a:bodyPr wrap="square">
+            <a:spAutoFit/>
+          </a:bodyPr>
+          <a:lstStyle/>
+          <a:p>
+            <a:pPr algn="ctr"/>
+            <a:r>
+              <a:rPr sz="1300" b="1" i="0">
+                <a:solidFill>
+                  <a:srgbClr val="B71C1C"/>
+                </a:solidFill>
+                <a:latin typeface="Calibri"/>
+              </a:rPr>
+              <a:t>⚠  Ao ritmo atual de convergência (~0,02 log-pontos/ano), eliminar o gap levaria mais de 100 anos.</a:t>
+            </a:r>
+          </a:p>
+        </p:txBody>
+      </p:sp>
+      <p:sp>
+        <p:nvSpPr>
+          <p:cNvPr id="24" name="Rectangle 23"/>
+          <p:cNvSpPr/>
+          <p:nvPr/>
+        </p:nvSpPr>
+        <p:spPr>
+          <a:xfrm>
+            <a:off x="0" y="6601968"/>
+            <a:ext cx="12188952" cy="256032"/>
+          </a:xfrm>
+          <a:prstGeom prst="rect">
+            <a:avLst/>
+          </a:prstGeom>
+          <a:solidFill>
+            <a:srgbClr val="1F3864"/>
+          </a:solidFill>
+          <a:ln/>
+        </p:spPr>
+        <p:style>
+          <a:lnRef idx="1">
+            <a:schemeClr val="accent1"/>
+          </a:lnRef>
+          <a:fillRef idx="3">
+            <a:schemeClr val="accent1"/>
+          </a:fillRef>
+          <a:effectRef idx="2">
+            <a:schemeClr val="accent1"/>
+          </a:effectRef>
+          <a:fontRef idx="minor">
+            <a:schemeClr val="lt1"/>
+          </a:fontRef>
+        </p:style>
+        <p:txBody>
+          <a:bodyPr rtlCol="0" anchor="ctr"/>
+          <a:lstStyle/>
+          <a:p>
+            <a:pPr algn="ctr"/>
+          </a:p>
+        </p:txBody>
+      </p:sp>
+      <p:sp>
+        <p:nvSpPr>
+          <p:cNvPr id="25" name="TextBox 24"/>
           <p:cNvSpPr txBox="1"/>
           <p:nvPr/>
         </p:nvSpPr>
@@ -22224,7 +22529,7 @@
       </p:sp>
       <p:sp>
         <p:nvSpPr>
-          <p:cNvPr id="11" name="TextBox 10"/>
+          <p:cNvPr id="26" name="TextBox 25"/>
           <p:cNvSpPr txBox="1"/>
           <p:nvPr/>
         </p:nvSpPr>
@@ -22252,7 +22557,7 @@
                 </a:solidFill>
                 <a:latin typeface="Calibri"/>
               </a:rPr>
-              <a:t>28/28</a:t>
+              <a:t>28/29</a:t>
             </a:r>
           </a:p>
         </p:txBody>
@@ -22284,7 +22589,7 @@
         <p:spPr>
           <a:xfrm>
             <a:off x="0" y="0"/>
-            <a:ext cx="12188952" cy="6858000"/>
+            <a:ext cx="12188952" cy="1005840"/>
           </a:xfrm>
           <a:prstGeom prst="rect">
             <a:avLst/>
@@ -22318,20 +22623,431 @@
       </p:sp>
       <p:sp>
         <p:nvSpPr>
-          <p:cNvPr id="3" name="Rectangle 2"/>
+          <p:cNvPr id="3" name="TextBox 2"/>
+          <p:cNvSpPr txBox="1"/>
+          <p:nvPr/>
+        </p:nvSpPr>
+        <p:spPr>
+          <a:xfrm>
+            <a:off x="274320" y="73152"/>
+            <a:ext cx="10972800" cy="502920"/>
+          </a:xfrm>
+          <a:prstGeom prst="rect">
+            <a:avLst/>
+          </a:prstGeom>
+          <a:noFill/>
+        </p:spPr>
+        <p:txBody>
+          <a:bodyPr wrap="square">
+            <a:spAutoFit/>
+          </a:bodyPr>
+          <a:lstStyle/>
+          <a:p>
+            <a:pPr algn="l"/>
+            <a:r>
+              <a:rPr sz="2600" b="1" i="0">
+                <a:solidFill>
+                  <a:srgbClr val="FFFFFF"/>
+                </a:solidFill>
+                <a:latin typeface="Calibri"/>
+              </a:rPr>
+              <a:t>28. Limitações e Agenda Futura</a:t>
+            </a:r>
+          </a:p>
+        </p:txBody>
+      </p:sp>
+      <p:sp>
+        <p:nvSpPr>
+          <p:cNvPr id="4" name="TextBox 3"/>
+          <p:cNvSpPr txBox="1"/>
+          <p:nvPr/>
+        </p:nvSpPr>
+        <p:spPr>
+          <a:xfrm>
+            <a:off x="274320" y="594360"/>
+            <a:ext cx="10972800" cy="347472"/>
+          </a:xfrm>
+          <a:prstGeom prst="rect">
+            <a:avLst/>
+          </a:prstGeom>
+          <a:noFill/>
+        </p:spPr>
+        <p:txBody>
+          <a:bodyPr wrap="square">
+            <a:spAutoFit/>
+          </a:bodyPr>
+          <a:lstStyle/>
+          <a:p>
+            <a:pPr algn="l"/>
+            <a:r>
+              <a:rPr sz="1400" b="0" i="0">
+                <a:solidFill>
+                  <a:srgbClr val="BBDEFB"/>
+                </a:solidFill>
+                <a:latin typeface="Calibri"/>
+              </a:rPr>
+              <a:t>Honestidade acadêmica: o que este trabalho não faz e por quê</a:t>
+            </a:r>
+          </a:p>
+        </p:txBody>
+      </p:sp>
+      <p:sp>
+        <p:nvSpPr>
+          <p:cNvPr id="5" name="TextBox 4"/>
+          <p:cNvSpPr txBox="1"/>
+          <p:nvPr/>
+        </p:nvSpPr>
+        <p:spPr>
+          <a:xfrm>
+            <a:off x="365760" y="1143000"/>
+            <a:ext cx="5486400" cy="365760"/>
+          </a:xfrm>
+          <a:prstGeom prst="rect">
+            <a:avLst/>
+          </a:prstGeom>
+          <a:noFill/>
+        </p:spPr>
+        <p:txBody>
+          <a:bodyPr wrap="square">
+            <a:spAutoFit/>
+          </a:bodyPr>
+          <a:lstStyle/>
+          <a:p>
+            <a:pPr algn="l"/>
+            <a:r>
+              <a:rPr sz="1600" b="1" i="0">
+                <a:solidFill>
+                  <a:srgbClr val="B71C1C"/>
+                </a:solidFill>
+                <a:latin typeface="Calibri"/>
+              </a:rPr>
+              <a:t>Limitações</a:t>
+            </a:r>
+          </a:p>
+        </p:txBody>
+      </p:sp>
+      <p:sp>
+        <p:nvSpPr>
+          <p:cNvPr id="6" name="TextBox 5"/>
+          <p:cNvSpPr txBox="1"/>
+          <p:nvPr/>
+        </p:nvSpPr>
+        <p:spPr>
+          <a:xfrm>
+            <a:off x="365760" y="1600200"/>
+            <a:ext cx="5669280" cy="3474720"/>
+          </a:xfrm>
+          <a:prstGeom prst="rect">
+            <a:avLst/>
+          </a:prstGeom>
+          <a:noFill/>
+        </p:spPr>
+        <p:txBody>
+          <a:bodyPr wrap="square">
+            <a:spAutoFit/>
+          </a:bodyPr>
+          <a:lstStyle/>
+          <a:p>
+            <a:pPr>
+              <a:spcAft>
+                <a:spcPts val="400"/>
+              </a:spcAft>
+            </a:pPr>
+            <a:r>
+              <a:rPr sz="1300" b="1">
+                <a:solidFill>
+                  <a:srgbClr val="B71C1C"/>
+                </a:solidFill>
+                <a:latin typeface="Calibri"/>
+              </a:rPr>
+              <a:t>▸  </a:t>
+            </a:r>
+            <a:r>
+              <a:rPr sz="1300">
+                <a:solidFill>
+                  <a:srgbClr val="212121"/>
+                </a:solidFill>
+                <a:latin typeface="Calibri"/>
+              </a:rPr>
+              <a:t>PNAD não permite experimentos causais — coeficientes são associações condicionais, não efeitos causais no sentido de Rubin/Pearl</a:t>
+            </a:r>
+          </a:p>
+          <a:p>
+            <a:pPr>
+              <a:spcAft>
+                <a:spcPts val="400"/>
+              </a:spcAft>
+            </a:pPr>
+            <a:r>
+              <a:rPr sz="1300" b="1">
+                <a:solidFill>
+                  <a:srgbClr val="B71C1C"/>
+                </a:solidFill>
+                <a:latin typeface="Calibri"/>
+              </a:rPr>
+              <a:t>▸  </a:t>
+            </a:r>
+            <a:r>
+              <a:rPr sz="1300">
+                <a:solidFill>
+                  <a:srgbClr val="212121"/>
+                </a:solidFill>
+                <a:latin typeface="Calibri"/>
+              </a:rPr>
+              <a:t>UPA como proxy de bairro: unidade de amostragem ≠ bairro administrativo</a:t>
+            </a:r>
+          </a:p>
+          <a:p>
+            <a:pPr>
+              <a:spcAft>
+                <a:spcPts val="400"/>
+              </a:spcAft>
+            </a:pPr>
+            <a:r>
+              <a:rPr sz="1300" b="1">
+                <a:solidFill>
+                  <a:srgbClr val="B71C1C"/>
+                </a:solidFill>
+                <a:latin typeface="Calibri"/>
+              </a:rPr>
+              <a:t>▸  </a:t>
+            </a:r>
+            <a:r>
+              <a:rPr sz="1300">
+                <a:solidFill>
+                  <a:srgbClr val="212121"/>
+                </a:solidFill>
+                <a:latin typeface="Calibri"/>
+              </a:rPr>
+              <a:t>GLMM logístico estimado na PEA completa via lme4::glmer (nAGQ=0, bobyqa, n=7,7M, 40,9k UPAs); random slope de negro estimado tanto no HLM (salário) quanto no GLMM (acesso, 1+negro|UF) — heterogeneidade geográfica confirmada (LRT p&lt;0,001)</a:t>
+            </a:r>
+          </a:p>
+          <a:p>
+            <a:pPr>
+              <a:spcAft>
+                <a:spcPts val="400"/>
+              </a:spcAft>
+            </a:pPr>
+            <a:r>
+              <a:rPr sz="1300" b="1">
+                <a:solidFill>
+                  <a:srgbClr val="B71C1C"/>
+                </a:solidFill>
+                <a:latin typeface="Calibri"/>
+              </a:rPr>
+              <a:t>▸  </a:t>
+            </a:r>
+            <a:r>
+              <a:rPr sz="1300">
+                <a:solidFill>
+                  <a:srgbClr val="212121"/>
+                </a:solidFill>
+                <a:latin typeface="Calibri"/>
+              </a:rPr>
+              <a:t>CBO auto-declarado pode ter viés de classificação por raça (deflation de ocupação)</a:t>
+            </a:r>
+          </a:p>
+        </p:txBody>
+      </p:sp>
+      <p:sp>
+        <p:nvSpPr>
+          <p:cNvPr id="7" name="TextBox 6"/>
+          <p:cNvSpPr txBox="1"/>
+          <p:nvPr/>
+        </p:nvSpPr>
+        <p:spPr>
+          <a:xfrm>
+            <a:off x="6400800" y="1143000"/>
+            <a:ext cx="5486400" cy="365760"/>
+          </a:xfrm>
+          <a:prstGeom prst="rect">
+            <a:avLst/>
+          </a:prstGeom>
+          <a:noFill/>
+        </p:spPr>
+        <p:txBody>
+          <a:bodyPr wrap="square">
+            <a:spAutoFit/>
+          </a:bodyPr>
+          <a:lstStyle/>
+          <a:p>
+            <a:pPr algn="l"/>
+            <a:r>
+              <a:rPr sz="1600" b="1" i="0">
+                <a:solidFill>
+                  <a:srgbClr val="1565C0"/>
+                </a:solidFill>
+                <a:latin typeface="Calibri"/>
+              </a:rPr>
+              <a:t>Agenda Futura</a:t>
+            </a:r>
+          </a:p>
+        </p:txBody>
+      </p:sp>
+      <p:sp>
+        <p:nvSpPr>
+          <p:cNvPr id="8" name="TextBox 7"/>
+          <p:cNvSpPr txBox="1"/>
+          <p:nvPr/>
+        </p:nvSpPr>
+        <p:spPr>
+          <a:xfrm>
+            <a:off x="6400800" y="1600200"/>
+            <a:ext cx="5669280" cy="3474720"/>
+          </a:xfrm>
+          <a:prstGeom prst="rect">
+            <a:avLst/>
+          </a:prstGeom>
+          <a:noFill/>
+        </p:spPr>
+        <p:txBody>
+          <a:bodyPr wrap="square">
+            <a:spAutoFit/>
+          </a:bodyPr>
+          <a:lstStyle/>
+          <a:p>
+            <a:pPr>
+              <a:spcAft>
+                <a:spcPts val="400"/>
+              </a:spcAft>
+            </a:pPr>
+            <a:r>
+              <a:rPr sz="1300" b="1">
+                <a:solidFill>
+                  <a:srgbClr val="1565C0"/>
+                </a:solidFill>
+                <a:latin typeface="Calibri"/>
+              </a:rPr>
+              <a:t>▸  </a:t>
+            </a:r>
+            <a:r>
+              <a:rPr sz="1300">
+                <a:solidFill>
+                  <a:srgbClr val="212121"/>
+                </a:solidFill>
+                <a:latin typeface="Calibri"/>
+              </a:rPr>
+              <a:t>Análise de variáveis instrumentais (IV) para identificação causal — distância à escola técnica como instrumento</a:t>
+            </a:r>
+          </a:p>
+          <a:p>
+            <a:pPr>
+              <a:spcAft>
+                <a:spcPts val="400"/>
+              </a:spcAft>
+            </a:pPr>
+            <a:r>
+              <a:rPr sz="1300" b="1">
+                <a:solidFill>
+                  <a:srgbClr val="1565C0"/>
+                </a:solidFill>
+                <a:latin typeface="Calibri"/>
+              </a:rPr>
+              <a:t>▸  </a:t>
+            </a:r>
+            <a:r>
+              <a:rPr sz="1300">
+                <a:solidFill>
+                  <a:srgbClr val="212121"/>
+                </a:solidFill>
+                <a:latin typeface="Calibri"/>
+              </a:rPr>
+              <a:t>RAIS linkada à PNAD para rastrear trajetórias de mobilidade intraempresa</a:t>
+            </a:r>
+          </a:p>
+          <a:p>
+            <a:pPr>
+              <a:spcAft>
+                <a:spcPts val="400"/>
+              </a:spcAft>
+            </a:pPr>
+            <a:r>
+              <a:rPr sz="1300" b="1">
+                <a:solidFill>
+                  <a:srgbClr val="1565C0"/>
+                </a:solidFill>
+                <a:latin typeface="Calibri"/>
+              </a:rPr>
+              <a:t>▸  </a:t>
+            </a:r>
+            <a:r>
+              <a:rPr sz="1300">
+                <a:solidFill>
+                  <a:srgbClr val="212121"/>
+                </a:solidFill>
+                <a:latin typeface="Calibri"/>
+              </a:rPr>
+              <a:t>Análise de mediação formal (path analysis) raça → ocupação → renda</a:t>
+            </a:r>
+          </a:p>
+          <a:p>
+            <a:pPr>
+              <a:spcAft>
+                <a:spcPts val="400"/>
+              </a:spcAft>
+            </a:pPr>
+            <a:r>
+              <a:rPr sz="1300" b="1">
+                <a:solidFill>
+                  <a:srgbClr val="1565C0"/>
+                </a:solidFill>
+                <a:latin typeface="Calibri"/>
+              </a:rPr>
+              <a:t>▸  </a:t>
+            </a:r>
+            <a:r>
+              <a:rPr sz="1300">
+                <a:solidFill>
+                  <a:srgbClr val="212121"/>
+                </a:solidFill>
+                <a:latin typeface="Calibri"/>
+              </a:rPr>
+              <a:t>Extensão ao setor público por UF — heterogeneidade do glass ceiling entre estados</a:t>
+            </a:r>
+          </a:p>
+          <a:p>
+            <a:pPr>
+              <a:spcAft>
+                <a:spcPts val="400"/>
+              </a:spcAft>
+            </a:pPr>
+            <a:r>
+              <a:rPr sz="1300" b="1">
+                <a:solidFill>
+                  <a:srgbClr val="1565C0"/>
+                </a:solidFill>
+                <a:latin typeface="Calibri"/>
+              </a:rPr>
+              <a:t>▸  </a:t>
+            </a:r>
+            <a:r>
+              <a:rPr sz="1300">
+                <a:solidFill>
+                  <a:srgbClr val="212121"/>
+                </a:solidFill>
+                <a:latin typeface="Calibri"/>
+              </a:rPr>
+              <a:t>Modelo longitudinal com painéis rotativos da PNAD (2T seguidos) para efeitos fixos de indivíduo</a:t>
+            </a:r>
+          </a:p>
+        </p:txBody>
+      </p:sp>
+      <p:sp>
+        <p:nvSpPr>
+          <p:cNvPr id="9" name="Rectangle 8"/>
           <p:cNvSpPr/>
           <p:nvPr/>
         </p:nvSpPr>
         <p:spPr>
           <a:xfrm>
-            <a:off x="0" y="0"/>
-            <a:ext cx="12188952" cy="731520"/>
+            <a:off x="0" y="6601968"/>
+            <a:ext cx="12188952" cy="256032"/>
           </a:xfrm>
           <a:prstGeom prst="rect">
             <a:avLst/>
           </a:prstGeom>
           <a:solidFill>
-            <a:srgbClr val="0D1F3C"/>
+            <a:srgbClr val="1F3864"/>
           </a:solidFill>
           <a:ln/>
         </p:spPr>
@@ -22359,14 +23075,14 @@
       </p:sp>
       <p:sp>
         <p:nvSpPr>
-          <p:cNvPr id="4" name="TextBox 3"/>
-          <p:cNvSpPr txBox="1"/>
-          <p:nvPr/>
-        </p:nvSpPr>
-        <p:spPr>
-          <a:xfrm>
-            <a:off x="365760" y="91440"/>
-            <a:ext cx="10972800" cy="594360"/>
+          <p:cNvPr id="10" name="TextBox 9"/>
+          <p:cNvSpPr txBox="1"/>
+          <p:nvPr/>
+        </p:nvSpPr>
+        <p:spPr>
+          <a:xfrm>
+            <a:off x="137160" y="6629400"/>
+            <a:ext cx="10058400" cy="228600"/>
           </a:xfrm>
           <a:prstGeom prst="rect">
             <a:avLst/>
@@ -22381,873 +23097,48 @@
           <a:p>
             <a:pPr algn="l"/>
             <a:r>
-              <a:rPr sz="2600" b="1" i="0">
+              <a:rPr sz="850" b="0" i="0">
+                <a:solidFill>
+                  <a:srgbClr val="BBDEFB"/>
+                </a:solidFill>
+                <a:latin typeface="Calibri"/>
+              </a:rPr>
+              <a:t>Ricardo Calheiros  |  MBA USP/ESALQ  |  Racismo Estrutural e Mercado de Trabalho</a:t>
+            </a:r>
+          </a:p>
+        </p:txBody>
+      </p:sp>
+      <p:sp>
+        <p:nvSpPr>
+          <p:cNvPr id="11" name="TextBox 10"/>
+          <p:cNvSpPr txBox="1"/>
+          <p:nvPr/>
+        </p:nvSpPr>
+        <p:spPr>
+          <a:xfrm>
+            <a:off x="11704320" y="6629400"/>
+            <a:ext cx="457200" cy="228600"/>
+          </a:xfrm>
+          <a:prstGeom prst="rect">
+            <a:avLst/>
+          </a:prstGeom>
+          <a:noFill/>
+        </p:spPr>
+        <p:txBody>
+          <a:bodyPr wrap="square">
+            <a:spAutoFit/>
+          </a:bodyPr>
+          <a:lstStyle/>
+          <a:p>
+            <a:pPr algn="r"/>
+            <a:r>
+              <a:rPr sz="850" b="0" i="0">
                 <a:solidFill>
                   <a:srgbClr val="FFFFFF"/>
                 </a:solidFill>
                 <a:latin typeface="Calibri"/>
               </a:rPr>
-              <a:t>28. Conclusão</a:t>
-            </a:r>
-          </a:p>
-        </p:txBody>
-      </p:sp>
-      <p:sp>
-        <p:nvSpPr>
-          <p:cNvPr id="5" name="Rectangle 4"/>
-          <p:cNvSpPr/>
-          <p:nvPr/>
-        </p:nvSpPr>
-        <p:spPr>
-          <a:xfrm>
-            <a:off x="365760" y="868680"/>
-            <a:ext cx="2743200" cy="1371600"/>
-          </a:xfrm>
-          <a:prstGeom prst="rect">
-            <a:avLst/>
-          </a:prstGeom>
-          <a:solidFill>
-            <a:srgbClr val="1A305C"/>
-          </a:solidFill>
-          <a:ln w="12700">
-            <a:solidFill>
-              <a:srgbClr val="FF8F00"/>
-            </a:solidFill>
-          </a:ln>
-        </p:spPr>
-        <p:style>
-          <a:lnRef idx="1">
-            <a:schemeClr val="accent1"/>
-          </a:lnRef>
-          <a:fillRef idx="3">
-            <a:schemeClr val="accent1"/>
-          </a:fillRef>
-          <a:effectRef idx="2">
-            <a:schemeClr val="accent1"/>
-          </a:effectRef>
-          <a:fontRef idx="minor">
-            <a:schemeClr val="lt1"/>
-          </a:fontRef>
-        </p:style>
-        <p:txBody>
-          <a:bodyPr rtlCol="0" anchor="ctr"/>
-          <a:lstStyle/>
-          <a:p>
-            <a:pPr algn="ctr"/>
-          </a:p>
-        </p:txBody>
-      </p:sp>
-      <p:sp>
-        <p:nvSpPr>
-          <p:cNvPr id="6" name="TextBox 5"/>
-          <p:cNvSpPr txBox="1"/>
-          <p:nvPr/>
-        </p:nvSpPr>
-        <p:spPr>
-          <a:xfrm>
-            <a:off x="457200" y="914400"/>
-            <a:ext cx="2560320" cy="685800"/>
-          </a:xfrm>
-          <a:prstGeom prst="rect">
-            <a:avLst/>
-          </a:prstGeom>
-          <a:noFill/>
-        </p:spPr>
-        <p:txBody>
-          <a:bodyPr wrap="square">
-            <a:spAutoFit/>
-          </a:bodyPr>
-          <a:lstStyle/>
-          <a:p>
-            <a:pPr algn="ctr"/>
-            <a:r>
-              <a:rPr sz="3000" b="1" i="0">
-                <a:solidFill>
-                  <a:srgbClr val="FF8F00"/>
-                </a:solidFill>
-                <a:latin typeface="Calibri"/>
-              </a:rPr>
-              <a:t>19,3%</a:t>
-            </a:r>
-          </a:p>
-        </p:txBody>
-      </p:sp>
-      <p:sp>
-        <p:nvSpPr>
-          <p:cNvPr id="7" name="TextBox 6"/>
-          <p:cNvSpPr txBox="1"/>
-          <p:nvPr/>
-        </p:nvSpPr>
-        <p:spPr>
-          <a:xfrm>
-            <a:off x="457200" y="1600200"/>
-            <a:ext cx="2560320" cy="548640"/>
-          </a:xfrm>
-          <a:prstGeom prst="rect">
-            <a:avLst/>
-          </a:prstGeom>
-          <a:noFill/>
-        </p:spPr>
-        <p:txBody>
-          <a:bodyPr wrap="square">
-            <a:spAutoFit/>
-          </a:bodyPr>
-          <a:lstStyle/>
-          <a:p>
-            <a:pPr algn="ctr"/>
-            <a:r>
-              <a:rPr sz="1100" b="0" i="0">
-                <a:solidFill>
-                  <a:srgbClr val="FFFFFF"/>
-                </a:solidFill>
-                <a:latin typeface="Calibri"/>
-              </a:rPr>
-              <a:t>Gap racial bruto
-(M1 HLM)</a:t>
-            </a:r>
-          </a:p>
-        </p:txBody>
-      </p:sp>
-      <p:sp>
-        <p:nvSpPr>
-          <p:cNvPr id="8" name="Rectangle 7"/>
-          <p:cNvSpPr/>
-          <p:nvPr/>
-        </p:nvSpPr>
-        <p:spPr>
-          <a:xfrm>
-            <a:off x="3291840" y="868680"/>
-            <a:ext cx="2743200" cy="1371600"/>
-          </a:xfrm>
-          <a:prstGeom prst="rect">
-            <a:avLst/>
-          </a:prstGeom>
-          <a:solidFill>
-            <a:srgbClr val="1A305C"/>
-          </a:solidFill>
-          <a:ln w="12700">
-            <a:solidFill>
-              <a:srgbClr val="FF8F00"/>
-            </a:solidFill>
-          </a:ln>
-        </p:spPr>
-        <p:style>
-          <a:lnRef idx="1">
-            <a:schemeClr val="accent1"/>
-          </a:lnRef>
-          <a:fillRef idx="3">
-            <a:schemeClr val="accent1"/>
-          </a:fillRef>
-          <a:effectRef idx="2">
-            <a:schemeClr val="accent1"/>
-          </a:effectRef>
-          <a:fontRef idx="minor">
-            <a:schemeClr val="lt1"/>
-          </a:fontRef>
-        </p:style>
-        <p:txBody>
-          <a:bodyPr rtlCol="0" anchor="ctr"/>
-          <a:lstStyle/>
-          <a:p>
-            <a:pPr algn="ctr"/>
-          </a:p>
-        </p:txBody>
-      </p:sp>
-      <p:sp>
-        <p:nvSpPr>
-          <p:cNvPr id="9" name="TextBox 8"/>
-          <p:cNvSpPr txBox="1"/>
-          <p:nvPr/>
-        </p:nvSpPr>
-        <p:spPr>
-          <a:xfrm>
-            <a:off x="3383280" y="914400"/>
-            <a:ext cx="2560320" cy="685800"/>
-          </a:xfrm>
-          <a:prstGeom prst="rect">
-            <a:avLst/>
-          </a:prstGeom>
-          <a:noFill/>
-        </p:spPr>
-        <p:txBody>
-          <a:bodyPr wrap="square">
-            <a:spAutoFit/>
-          </a:bodyPr>
-          <a:lstStyle/>
-          <a:p>
-            <a:pPr algn="ctr"/>
-            <a:r>
-              <a:rPr sz="3000" b="1" i="0">
-                <a:solidFill>
-                  <a:srgbClr val="FF8F00"/>
-                </a:solidFill>
-                <a:latin typeface="Calibri"/>
-              </a:rPr>
-              <a:t>6,2%</a:t>
-            </a:r>
-          </a:p>
-        </p:txBody>
-      </p:sp>
-      <p:sp>
-        <p:nvSpPr>
-          <p:cNvPr id="10" name="TextBox 9"/>
-          <p:cNvSpPr txBox="1"/>
-          <p:nvPr/>
-        </p:nvSpPr>
-        <p:spPr>
-          <a:xfrm>
-            <a:off x="3383280" y="1600200"/>
-            <a:ext cx="2560320" cy="548640"/>
-          </a:xfrm>
-          <a:prstGeom prst="rect">
-            <a:avLst/>
-          </a:prstGeom>
-          <a:noFill/>
-        </p:spPr>
-        <p:txBody>
-          <a:bodyPr wrap="square">
-            <a:spAutoFit/>
-          </a:bodyPr>
-          <a:lstStyle/>
-          <a:p>
-            <a:pPr algn="ctr"/>
-            <a:r>
-              <a:rPr sz="1100" b="0" i="0">
-                <a:solidFill>
-                  <a:srgbClr val="FFFFFF"/>
-                </a:solidFill>
-                <a:latin typeface="Calibri"/>
-              </a:rPr>
-              <a:t>Discriminação pura
-(M4 HLM)</a:t>
-            </a:r>
-          </a:p>
-        </p:txBody>
-      </p:sp>
-      <p:sp>
-        <p:nvSpPr>
-          <p:cNvPr id="11" name="Rectangle 10"/>
-          <p:cNvSpPr/>
-          <p:nvPr/>
-        </p:nvSpPr>
-        <p:spPr>
-          <a:xfrm>
-            <a:off x="6217920" y="868680"/>
-            <a:ext cx="2743200" cy="1371600"/>
-          </a:xfrm>
-          <a:prstGeom prst="rect">
-            <a:avLst/>
-          </a:prstGeom>
-          <a:solidFill>
-            <a:srgbClr val="1A305C"/>
-          </a:solidFill>
-          <a:ln w="12700">
-            <a:solidFill>
-              <a:srgbClr val="FF8F00"/>
-            </a:solidFill>
-          </a:ln>
-        </p:spPr>
-        <p:style>
-          <a:lnRef idx="1">
-            <a:schemeClr val="accent1"/>
-          </a:lnRef>
-          <a:fillRef idx="3">
-            <a:schemeClr val="accent1"/>
-          </a:fillRef>
-          <a:effectRef idx="2">
-            <a:schemeClr val="accent1"/>
-          </a:effectRef>
-          <a:fontRef idx="minor">
-            <a:schemeClr val="lt1"/>
-          </a:fontRef>
-        </p:style>
-        <p:txBody>
-          <a:bodyPr rtlCol="0" anchor="ctr"/>
-          <a:lstStyle/>
-          <a:p>
-            <a:pPr algn="ctr"/>
-          </a:p>
-        </p:txBody>
-      </p:sp>
-      <p:sp>
-        <p:nvSpPr>
-          <p:cNvPr id="12" name="TextBox 11"/>
-          <p:cNvSpPr txBox="1"/>
-          <p:nvPr/>
-        </p:nvSpPr>
-        <p:spPr>
-          <a:xfrm>
-            <a:off x="6309360" y="914400"/>
-            <a:ext cx="2560320" cy="685800"/>
-          </a:xfrm>
-          <a:prstGeom prst="rect">
-            <a:avLst/>
-          </a:prstGeom>
-          <a:noFill/>
-        </p:spPr>
-        <p:txBody>
-          <a:bodyPr wrap="square">
-            <a:spAutoFit/>
-          </a:bodyPr>
-          <a:lstStyle/>
-          <a:p>
-            <a:pPr algn="ctr"/>
-            <a:r>
-              <a:rPr sz="3000" b="1" i="0">
-                <a:solidFill>
-                  <a:srgbClr val="FF8F00"/>
-                </a:solidFill>
-                <a:latin typeface="Calibri"/>
-              </a:rPr>
-              <a:t>OR=0,693</a:t>
-            </a:r>
-          </a:p>
-        </p:txBody>
-      </p:sp>
-      <p:sp>
-        <p:nvSpPr>
-          <p:cNvPr id="13" name="TextBox 12"/>
-          <p:cNvSpPr txBox="1"/>
-          <p:nvPr/>
-        </p:nvSpPr>
-        <p:spPr>
-          <a:xfrm>
-            <a:off x="6309360" y="1600200"/>
-            <a:ext cx="2560320" cy="548640"/>
-          </a:xfrm>
-          <a:prstGeom prst="rect">
-            <a:avLst/>
-          </a:prstGeom>
-          <a:noFill/>
-        </p:spPr>
-        <p:txBody>
-          <a:bodyPr wrap="square">
-            <a:spAutoFit/>
-          </a:bodyPr>
-          <a:lstStyle/>
-          <a:p>
-            <a:pPr algn="ctr"/>
-            <a:r>
-              <a:rPr sz="1100" b="0" i="0">
-                <a:solidFill>
-                  <a:srgbClr val="FFFFFF"/>
-                </a:solidFill>
-                <a:latin typeface="Calibri"/>
-              </a:rPr>
-              <a:t>Acesso qualificado
-(GLMM M2, lme4)</a:t>
-            </a:r>
-          </a:p>
-        </p:txBody>
-      </p:sp>
-      <p:sp>
-        <p:nvSpPr>
-          <p:cNvPr id="14" name="Rectangle 13"/>
-          <p:cNvSpPr/>
-          <p:nvPr/>
-        </p:nvSpPr>
-        <p:spPr>
-          <a:xfrm>
-            <a:off x="9144000" y="868680"/>
-            <a:ext cx="2743200" cy="1371600"/>
-          </a:xfrm>
-          <a:prstGeom prst="rect">
-            <a:avLst/>
-          </a:prstGeom>
-          <a:solidFill>
-            <a:srgbClr val="1A305C"/>
-          </a:solidFill>
-          <a:ln w="12700">
-            <a:solidFill>
-              <a:srgbClr val="FF8F00"/>
-            </a:solidFill>
-          </a:ln>
-        </p:spPr>
-        <p:style>
-          <a:lnRef idx="1">
-            <a:schemeClr val="accent1"/>
-          </a:lnRef>
-          <a:fillRef idx="3">
-            <a:schemeClr val="accent1"/>
-          </a:fillRef>
-          <a:effectRef idx="2">
-            <a:schemeClr val="accent1"/>
-          </a:effectRef>
-          <a:fontRef idx="minor">
-            <a:schemeClr val="lt1"/>
-          </a:fontRef>
-        </p:style>
-        <p:txBody>
-          <a:bodyPr rtlCol="0" anchor="ctr"/>
-          <a:lstStyle/>
-          <a:p>
-            <a:pPr algn="ctr"/>
-          </a:p>
-        </p:txBody>
-      </p:sp>
-      <p:sp>
-        <p:nvSpPr>
-          <p:cNvPr id="15" name="TextBox 14"/>
-          <p:cNvSpPr txBox="1"/>
-          <p:nvPr/>
-        </p:nvSpPr>
-        <p:spPr>
-          <a:xfrm>
-            <a:off x="9235440" y="914400"/>
-            <a:ext cx="2560320" cy="685800"/>
-          </a:xfrm>
-          <a:prstGeom prst="rect">
-            <a:avLst/>
-          </a:prstGeom>
-          <a:noFill/>
-        </p:spPr>
-        <p:txBody>
-          <a:bodyPr wrap="square">
-            <a:spAutoFit/>
-          </a:bodyPr>
-          <a:lstStyle/>
-          <a:p>
-            <a:pPr algn="ctr"/>
-            <a:r>
-              <a:rPr sz="3000" b="1" i="0">
-                <a:solidFill>
-                  <a:srgbClr val="FF8F00"/>
-                </a:solidFill>
-                <a:latin typeface="Calibri"/>
-              </a:rPr>
-              <a:t>χ²=191k</a:t>
-            </a:r>
-          </a:p>
-        </p:txBody>
-      </p:sp>
-      <p:sp>
-        <p:nvSpPr>
-          <p:cNvPr id="16" name="TextBox 15"/>
-          <p:cNvSpPr txBox="1"/>
-          <p:nvPr/>
-        </p:nvSpPr>
-        <p:spPr>
-          <a:xfrm>
-            <a:off x="9235440" y="1600200"/>
-            <a:ext cx="2560320" cy="548640"/>
-          </a:xfrm>
-          <a:prstGeom prst="rect">
-            <a:avLst/>
-          </a:prstGeom>
-          <a:noFill/>
-        </p:spPr>
-        <p:txBody>
-          <a:bodyPr wrap="square">
-            <a:spAutoFit/>
-          </a:bodyPr>
-          <a:lstStyle/>
-          <a:p>
-            <a:pPr algn="ctr"/>
-            <a:r>
-              <a:rPr sz="1100" b="0" i="0">
-                <a:solidFill>
-                  <a:srgbClr val="FFFFFF"/>
-                </a:solidFill>
-                <a:latin typeface="Calibri"/>
-              </a:rPr>
-              <a:t>LRT confirma
-hierarquia UPA</a:t>
-            </a:r>
-          </a:p>
-        </p:txBody>
-      </p:sp>
-      <p:sp>
-        <p:nvSpPr>
-          <p:cNvPr id="17" name="Rectangle 16"/>
-          <p:cNvSpPr/>
-          <p:nvPr/>
-        </p:nvSpPr>
-        <p:spPr>
-          <a:xfrm>
-            <a:off x="274320" y="2377440"/>
-            <a:ext cx="11612880" cy="749808"/>
-          </a:xfrm>
-          <a:prstGeom prst="rect">
-            <a:avLst/>
-          </a:prstGeom>
-          <a:solidFill>
-            <a:srgbClr val="0F274A"/>
-          </a:solidFill>
-          <a:ln w="7620">
-            <a:solidFill>
-              <a:srgbClr val="FF8F00"/>
-            </a:solidFill>
-          </a:ln>
-        </p:spPr>
-        <p:style>
-          <a:lnRef idx="1">
-            <a:schemeClr val="accent1"/>
-          </a:lnRef>
-          <a:fillRef idx="3">
-            <a:schemeClr val="accent1"/>
-          </a:fillRef>
-          <a:effectRef idx="2">
-            <a:schemeClr val="accent1"/>
-          </a:effectRef>
-          <a:fontRef idx="minor">
-            <a:schemeClr val="lt1"/>
-          </a:fontRef>
-        </p:style>
-        <p:txBody>
-          <a:bodyPr rtlCol="0" anchor="ctr"/>
-          <a:lstStyle/>
-          <a:p>
-            <a:pPr algn="ctr"/>
-          </a:p>
-        </p:txBody>
-      </p:sp>
-      <p:sp>
-        <p:nvSpPr>
-          <p:cNvPr id="18" name="TextBox 17"/>
-          <p:cNvSpPr txBox="1"/>
-          <p:nvPr/>
-        </p:nvSpPr>
-        <p:spPr>
-          <a:xfrm>
-            <a:off x="457200" y="2423160"/>
-            <a:ext cx="11247120" cy="685800"/>
-          </a:xfrm>
-          <a:prstGeom prst="rect">
-            <a:avLst/>
-          </a:prstGeom>
-          <a:noFill/>
-        </p:spPr>
-        <p:txBody>
-          <a:bodyPr wrap="square">
-            <a:spAutoFit/>
-          </a:bodyPr>
-          <a:lstStyle/>
-          <a:p>
-            <a:pPr algn="l"/>
-            <a:r>
-              <a:rPr sz="1300" b="0" i="0">
-                <a:solidFill>
-                  <a:srgbClr val="FFFFFF"/>
-                </a:solidFill>
-                <a:latin typeface="Calibri"/>
-              </a:rPr>
-              <a:t>1. A desigualdade racial no mercado de trabalho brasileiro é estrutural, multicausal e resistente à convergência espontânea.</a:t>
-            </a:r>
-          </a:p>
-        </p:txBody>
-      </p:sp>
-      <p:sp>
-        <p:nvSpPr>
-          <p:cNvPr id="19" name="Rectangle 18"/>
-          <p:cNvSpPr/>
-          <p:nvPr/>
-        </p:nvSpPr>
-        <p:spPr>
-          <a:xfrm>
-            <a:off x="274320" y="3246120"/>
-            <a:ext cx="11612880" cy="749808"/>
-          </a:xfrm>
-          <a:prstGeom prst="rect">
-            <a:avLst/>
-          </a:prstGeom>
-          <a:solidFill>
-            <a:srgbClr val="0F274A"/>
-          </a:solidFill>
-          <a:ln w="7620">
-            <a:solidFill>
-              <a:srgbClr val="1565C0"/>
-            </a:solidFill>
-          </a:ln>
-        </p:spPr>
-        <p:style>
-          <a:lnRef idx="1">
-            <a:schemeClr val="accent1"/>
-          </a:lnRef>
-          <a:fillRef idx="3">
-            <a:schemeClr val="accent1"/>
-          </a:fillRef>
-          <a:effectRef idx="2">
-            <a:schemeClr val="accent1"/>
-          </a:effectRef>
-          <a:fontRef idx="minor">
-            <a:schemeClr val="lt1"/>
-          </a:fontRef>
-        </p:style>
-        <p:txBody>
-          <a:bodyPr rtlCol="0" anchor="ctr"/>
-          <a:lstStyle/>
-          <a:p>
-            <a:pPr algn="ctr"/>
-          </a:p>
-        </p:txBody>
-      </p:sp>
-      <p:sp>
-        <p:nvSpPr>
-          <p:cNvPr id="20" name="TextBox 19"/>
-          <p:cNvSpPr txBox="1"/>
-          <p:nvPr/>
-        </p:nvSpPr>
-        <p:spPr>
-          <a:xfrm>
-            <a:off x="457200" y="3291840"/>
-            <a:ext cx="11247120" cy="685800"/>
-          </a:xfrm>
-          <a:prstGeom prst="rect">
-            <a:avLst/>
-          </a:prstGeom>
-          <a:noFill/>
-        </p:spPr>
-        <p:txBody>
-          <a:bodyPr wrap="square">
-            <a:spAutoFit/>
-          </a:bodyPr>
-          <a:lstStyle/>
-          <a:p>
-            <a:pPr algn="l"/>
-            <a:r>
-              <a:rPr sz="1300" b="0" i="0">
-                <a:solidFill>
-                  <a:srgbClr val="FFFFFF"/>
-                </a:solidFill>
-                <a:latin typeface="Calibri"/>
-              </a:rPr>
-              <a:t>2. A discriminação opera em dois estágios independentes: barreiras de ACESSO a ocupações qualificadas (GLMM: OR=0,693, AME=−4,73 p.p.) e discriminação de REMUNERAÇÃO dentro das mesmas funções (HLM M4: 6,2%).</a:t>
-            </a:r>
-          </a:p>
-        </p:txBody>
-      </p:sp>
-      <p:sp>
-        <p:nvSpPr>
-          <p:cNvPr id="21" name="Rectangle 20"/>
-          <p:cNvSpPr/>
-          <p:nvPr/>
-        </p:nvSpPr>
-        <p:spPr>
-          <a:xfrm>
-            <a:off x="274320" y="4114800"/>
-            <a:ext cx="11612880" cy="749808"/>
-          </a:xfrm>
-          <a:prstGeom prst="rect">
-            <a:avLst/>
-          </a:prstGeom>
-          <a:solidFill>
-            <a:srgbClr val="0F274A"/>
-          </a:solidFill>
-          <a:ln w="7620">
-            <a:solidFill>
-              <a:srgbClr val="1565C0"/>
-            </a:solidFill>
-          </a:ln>
-        </p:spPr>
-        <p:style>
-          <a:lnRef idx="1">
-            <a:schemeClr val="accent1"/>
-          </a:lnRef>
-          <a:fillRef idx="3">
-            <a:schemeClr val="accent1"/>
-          </a:fillRef>
-          <a:effectRef idx="2">
-            <a:schemeClr val="accent1"/>
-          </a:effectRef>
-          <a:fontRef idx="minor">
-            <a:schemeClr val="lt1"/>
-          </a:fontRef>
-        </p:style>
-        <p:txBody>
-          <a:bodyPr rtlCol="0" anchor="ctr"/>
-          <a:lstStyle/>
-          <a:p>
-            <a:pPr algn="ctr"/>
-          </a:p>
-        </p:txBody>
-      </p:sp>
-      <p:sp>
-        <p:nvSpPr>
-          <p:cNvPr id="22" name="TextBox 21"/>
-          <p:cNvSpPr txBox="1"/>
-          <p:nvPr/>
-        </p:nvSpPr>
-        <p:spPr>
-          <a:xfrm>
-            <a:off x="457200" y="4160520"/>
-            <a:ext cx="11247120" cy="685800"/>
-          </a:xfrm>
-          <a:prstGeom prst="rect">
-            <a:avLst/>
-          </a:prstGeom>
-          <a:noFill/>
-        </p:spPr>
-        <p:txBody>
-          <a:bodyPr wrap="square">
-            <a:spAutoFit/>
-          </a:bodyPr>
-          <a:lstStyle/>
-          <a:p>
-            <a:pPr algn="l"/>
-            <a:r>
-              <a:rPr sz="1300" b="0" i="0">
-                <a:solidFill>
-                  <a:srgbClr val="FFFFFF"/>
-                </a:solidFill>
-                <a:latin typeface="Calibri"/>
-              </a:rPr>
-              <a:t>3. O glass ceiling racial é real e crescente no topo da distribuição — confirmado formalmente pela regressão quantílica e consistente com o IR=0,47 nas capitais.</a:t>
-            </a:r>
-          </a:p>
-        </p:txBody>
-      </p:sp>
-      <p:sp>
-        <p:nvSpPr>
-          <p:cNvPr id="23" name="Rectangle 22"/>
-          <p:cNvSpPr/>
-          <p:nvPr/>
-        </p:nvSpPr>
-        <p:spPr>
-          <a:xfrm>
-            <a:off x="274320" y="4983480"/>
-            <a:ext cx="11612880" cy="749808"/>
-          </a:xfrm>
-          <a:prstGeom prst="rect">
-            <a:avLst/>
-          </a:prstGeom>
-          <a:solidFill>
-            <a:srgbClr val="0F274A"/>
-          </a:solidFill>
-          <a:ln w="7620">
-            <a:solidFill>
-              <a:srgbClr val="1565C0"/>
-            </a:solidFill>
-          </a:ln>
-        </p:spPr>
-        <p:style>
-          <a:lnRef idx="1">
-            <a:schemeClr val="accent1"/>
-          </a:lnRef>
-          <a:fillRef idx="3">
-            <a:schemeClr val="accent1"/>
-          </a:fillRef>
-          <a:effectRef idx="2">
-            <a:schemeClr val="accent1"/>
-          </a:effectRef>
-          <a:fontRef idx="minor">
-            <a:schemeClr val="lt1"/>
-          </a:fontRef>
-        </p:style>
-        <p:txBody>
-          <a:bodyPr rtlCol="0" anchor="ctr"/>
-          <a:lstStyle/>
-          <a:p>
-            <a:pPr algn="ctr"/>
-          </a:p>
-        </p:txBody>
-      </p:sp>
-      <p:sp>
-        <p:nvSpPr>
-          <p:cNvPr id="24" name="TextBox 23"/>
-          <p:cNvSpPr txBox="1"/>
-          <p:nvPr/>
-        </p:nvSpPr>
-        <p:spPr>
-          <a:xfrm>
-            <a:off x="457200" y="5029200"/>
-            <a:ext cx="11247120" cy="685800"/>
-          </a:xfrm>
-          <a:prstGeom prst="rect">
-            <a:avLst/>
-          </a:prstGeom>
-          <a:noFill/>
-        </p:spPr>
-        <p:txBody>
-          <a:bodyPr wrap="square">
-            <a:spAutoFit/>
-          </a:bodyPr>
-          <a:lstStyle/>
-          <a:p>
-            <a:pPr algn="l"/>
-            <a:r>
-              <a:rPr sz="1300" b="0" i="0">
-                <a:solidFill>
-                  <a:srgbClr val="FFFFFF"/>
-                </a:solidFill>
-                <a:latin typeface="Calibri"/>
-              </a:rPr>
-              <a:t>4. Políticas que atuam apenas no gap salarial direto atacam 16% do problema. Os 84% restantes requerem ação nas portas de entrada das ocupações de alto prestígio.</a:t>
-            </a:r>
-          </a:p>
-        </p:txBody>
-      </p:sp>
-      <p:sp>
-        <p:nvSpPr>
-          <p:cNvPr id="25" name="Rectangle 24"/>
-          <p:cNvSpPr/>
-          <p:nvPr/>
-        </p:nvSpPr>
-        <p:spPr>
-          <a:xfrm>
-            <a:off x="0" y="6400800"/>
-            <a:ext cx="12188952" cy="457200"/>
-          </a:xfrm>
-          <a:prstGeom prst="rect">
-            <a:avLst/>
-          </a:prstGeom>
-          <a:solidFill>
-            <a:srgbClr val="0D1F3C"/>
-          </a:solidFill>
-          <a:ln/>
-        </p:spPr>
-        <p:style>
-          <a:lnRef idx="1">
-            <a:schemeClr val="accent1"/>
-          </a:lnRef>
-          <a:fillRef idx="3">
-            <a:schemeClr val="accent1"/>
-          </a:fillRef>
-          <a:effectRef idx="2">
-            <a:schemeClr val="accent1"/>
-          </a:effectRef>
-          <a:fontRef idx="minor">
-            <a:schemeClr val="lt1"/>
-          </a:fontRef>
-        </p:style>
-        <p:txBody>
-          <a:bodyPr rtlCol="0" anchor="ctr"/>
-          <a:lstStyle/>
-          <a:p>
-            <a:pPr algn="ctr"/>
-          </a:p>
-        </p:txBody>
-      </p:sp>
-      <p:sp>
-        <p:nvSpPr>
-          <p:cNvPr id="26" name="TextBox 25"/>
-          <p:cNvSpPr txBox="1"/>
-          <p:nvPr/>
-        </p:nvSpPr>
-        <p:spPr>
-          <a:xfrm>
-            <a:off x="274320" y="6446520"/>
-            <a:ext cx="11612880" cy="365760"/>
-          </a:xfrm>
-          <a:prstGeom prst="rect">
-            <a:avLst/>
-          </a:prstGeom>
-          <a:noFill/>
-        </p:spPr>
-        <p:txBody>
-          <a:bodyPr wrap="square">
-            <a:spAutoFit/>
-          </a:bodyPr>
-          <a:lstStyle/>
-          <a:p>
-            <a:pPr algn="ctr"/>
-            <a:r>
-              <a:rPr sz="1100" b="0" i="0">
-                <a:solidFill>
-                  <a:srgbClr val="90A4AE"/>
-                </a:solidFill>
-                <a:latin typeface="Calibri"/>
-              </a:rPr>
-              <a:t>Ricardo Calheiros  |  MBA Data Science &amp; Analytics  |  USP/ESALQ  |  rickinrj@gmail.com</a:t>
+              <a:t>29/29</a:t>
             </a:r>
           </a:p>
         </p:txBody>
@@ -24506,7 +24397,1002 @@
                 </a:solidFill>
                 <a:latin typeface="Calibri"/>
               </a:rPr>
-              <a:t>3/28</a:t>
+              <a:t>3/29</a:t>
+            </a:r>
+          </a:p>
+        </p:txBody>
+      </p:sp>
+    </p:spTree>
+  </p:cSld>
+  <p:clrMapOvr>
+    <a:masterClrMapping/>
+  </p:clrMapOvr>
+</p:sld>
+</file>
+
+<file path=ppt/slides/slide30.xml><?xml version="1.0" encoding="utf-8"?>
+<p:sld xmlns:a="http://schemas.openxmlformats.org/drawingml/2006/main" xmlns:p="http://schemas.openxmlformats.org/presentationml/2006/main" xmlns:r="http://schemas.openxmlformats.org/officeDocument/2006/relationships">
+  <p:cSld>
+    <p:spTree>
+      <p:nvGrpSpPr>
+        <p:cNvPr id="1" name=""/>
+        <p:cNvGrpSpPr/>
+        <p:nvPr/>
+      </p:nvGrpSpPr>
+      <p:grpSpPr/>
+      <p:sp>
+        <p:nvSpPr>
+          <p:cNvPr id="2" name="Rectangle 1"/>
+          <p:cNvSpPr/>
+          <p:nvPr/>
+        </p:nvSpPr>
+        <p:spPr>
+          <a:xfrm>
+            <a:off x="0" y="0"/>
+            <a:ext cx="12188952" cy="6858000"/>
+          </a:xfrm>
+          <a:prstGeom prst="rect">
+            <a:avLst/>
+          </a:prstGeom>
+          <a:solidFill>
+            <a:srgbClr val="1F3864"/>
+          </a:solidFill>
+          <a:ln/>
+        </p:spPr>
+        <p:style>
+          <a:lnRef idx="1">
+            <a:schemeClr val="accent1"/>
+          </a:lnRef>
+          <a:fillRef idx="3">
+            <a:schemeClr val="accent1"/>
+          </a:fillRef>
+          <a:effectRef idx="2">
+            <a:schemeClr val="accent1"/>
+          </a:effectRef>
+          <a:fontRef idx="minor">
+            <a:schemeClr val="lt1"/>
+          </a:fontRef>
+        </p:style>
+        <p:txBody>
+          <a:bodyPr rtlCol="0" anchor="ctr"/>
+          <a:lstStyle/>
+          <a:p>
+            <a:pPr algn="ctr"/>
+          </a:p>
+        </p:txBody>
+      </p:sp>
+      <p:sp>
+        <p:nvSpPr>
+          <p:cNvPr id="3" name="Rectangle 2"/>
+          <p:cNvSpPr/>
+          <p:nvPr/>
+        </p:nvSpPr>
+        <p:spPr>
+          <a:xfrm>
+            <a:off x="0" y="0"/>
+            <a:ext cx="12188952" cy="731520"/>
+          </a:xfrm>
+          <a:prstGeom prst="rect">
+            <a:avLst/>
+          </a:prstGeom>
+          <a:solidFill>
+            <a:srgbClr val="0D1F3C"/>
+          </a:solidFill>
+          <a:ln/>
+        </p:spPr>
+        <p:style>
+          <a:lnRef idx="1">
+            <a:schemeClr val="accent1"/>
+          </a:lnRef>
+          <a:fillRef idx="3">
+            <a:schemeClr val="accent1"/>
+          </a:fillRef>
+          <a:effectRef idx="2">
+            <a:schemeClr val="accent1"/>
+          </a:effectRef>
+          <a:fontRef idx="minor">
+            <a:schemeClr val="lt1"/>
+          </a:fontRef>
+        </p:style>
+        <p:txBody>
+          <a:bodyPr rtlCol="0" anchor="ctr"/>
+          <a:lstStyle/>
+          <a:p>
+            <a:pPr algn="ctr"/>
+          </a:p>
+        </p:txBody>
+      </p:sp>
+      <p:sp>
+        <p:nvSpPr>
+          <p:cNvPr id="4" name="TextBox 3"/>
+          <p:cNvSpPr txBox="1"/>
+          <p:nvPr/>
+        </p:nvSpPr>
+        <p:spPr>
+          <a:xfrm>
+            <a:off x="365760" y="91440"/>
+            <a:ext cx="10972800" cy="594360"/>
+          </a:xfrm>
+          <a:prstGeom prst="rect">
+            <a:avLst/>
+          </a:prstGeom>
+          <a:noFill/>
+        </p:spPr>
+        <p:txBody>
+          <a:bodyPr wrap="square">
+            <a:spAutoFit/>
+          </a:bodyPr>
+          <a:lstStyle/>
+          <a:p>
+            <a:pPr algn="l"/>
+            <a:r>
+              <a:rPr sz="2600" b="1" i="0">
+                <a:solidFill>
+                  <a:srgbClr val="FFFFFF"/>
+                </a:solidFill>
+                <a:latin typeface="Calibri"/>
+              </a:rPr>
+              <a:t>29. Conclusão</a:t>
+            </a:r>
+          </a:p>
+        </p:txBody>
+      </p:sp>
+      <p:sp>
+        <p:nvSpPr>
+          <p:cNvPr id="5" name="Rectangle 4"/>
+          <p:cNvSpPr/>
+          <p:nvPr/>
+        </p:nvSpPr>
+        <p:spPr>
+          <a:xfrm>
+            <a:off x="365760" y="868680"/>
+            <a:ext cx="2743200" cy="1371600"/>
+          </a:xfrm>
+          <a:prstGeom prst="rect">
+            <a:avLst/>
+          </a:prstGeom>
+          <a:solidFill>
+            <a:srgbClr val="1A305C"/>
+          </a:solidFill>
+          <a:ln w="12700">
+            <a:solidFill>
+              <a:srgbClr val="FF8F00"/>
+            </a:solidFill>
+          </a:ln>
+        </p:spPr>
+        <p:style>
+          <a:lnRef idx="1">
+            <a:schemeClr val="accent1"/>
+          </a:lnRef>
+          <a:fillRef idx="3">
+            <a:schemeClr val="accent1"/>
+          </a:fillRef>
+          <a:effectRef idx="2">
+            <a:schemeClr val="accent1"/>
+          </a:effectRef>
+          <a:fontRef idx="minor">
+            <a:schemeClr val="lt1"/>
+          </a:fontRef>
+        </p:style>
+        <p:txBody>
+          <a:bodyPr rtlCol="0" anchor="ctr"/>
+          <a:lstStyle/>
+          <a:p>
+            <a:pPr algn="ctr"/>
+          </a:p>
+        </p:txBody>
+      </p:sp>
+      <p:sp>
+        <p:nvSpPr>
+          <p:cNvPr id="6" name="TextBox 5"/>
+          <p:cNvSpPr txBox="1"/>
+          <p:nvPr/>
+        </p:nvSpPr>
+        <p:spPr>
+          <a:xfrm>
+            <a:off x="457200" y="914400"/>
+            <a:ext cx="2560320" cy="685800"/>
+          </a:xfrm>
+          <a:prstGeom prst="rect">
+            <a:avLst/>
+          </a:prstGeom>
+          <a:noFill/>
+        </p:spPr>
+        <p:txBody>
+          <a:bodyPr wrap="square">
+            <a:spAutoFit/>
+          </a:bodyPr>
+          <a:lstStyle/>
+          <a:p>
+            <a:pPr algn="ctr"/>
+            <a:r>
+              <a:rPr sz="3000" b="1" i="0">
+                <a:solidFill>
+                  <a:srgbClr val="FF8F00"/>
+                </a:solidFill>
+                <a:latin typeface="Calibri"/>
+              </a:rPr>
+              <a:t>19,3%</a:t>
+            </a:r>
+          </a:p>
+        </p:txBody>
+      </p:sp>
+      <p:sp>
+        <p:nvSpPr>
+          <p:cNvPr id="7" name="TextBox 6"/>
+          <p:cNvSpPr txBox="1"/>
+          <p:nvPr/>
+        </p:nvSpPr>
+        <p:spPr>
+          <a:xfrm>
+            <a:off x="457200" y="1600200"/>
+            <a:ext cx="2560320" cy="548640"/>
+          </a:xfrm>
+          <a:prstGeom prst="rect">
+            <a:avLst/>
+          </a:prstGeom>
+          <a:noFill/>
+        </p:spPr>
+        <p:txBody>
+          <a:bodyPr wrap="square">
+            <a:spAutoFit/>
+          </a:bodyPr>
+          <a:lstStyle/>
+          <a:p>
+            <a:pPr algn="ctr"/>
+            <a:r>
+              <a:rPr sz="1100" b="0" i="0">
+                <a:solidFill>
+                  <a:srgbClr val="FFFFFF"/>
+                </a:solidFill>
+                <a:latin typeface="Calibri"/>
+              </a:rPr>
+              <a:t>Gap racial bruto
+(M1 HLM)</a:t>
+            </a:r>
+          </a:p>
+        </p:txBody>
+      </p:sp>
+      <p:sp>
+        <p:nvSpPr>
+          <p:cNvPr id="8" name="Rectangle 7"/>
+          <p:cNvSpPr/>
+          <p:nvPr/>
+        </p:nvSpPr>
+        <p:spPr>
+          <a:xfrm>
+            <a:off x="3291840" y="868680"/>
+            <a:ext cx="2743200" cy="1371600"/>
+          </a:xfrm>
+          <a:prstGeom prst="rect">
+            <a:avLst/>
+          </a:prstGeom>
+          <a:solidFill>
+            <a:srgbClr val="1A305C"/>
+          </a:solidFill>
+          <a:ln w="12700">
+            <a:solidFill>
+              <a:srgbClr val="FF8F00"/>
+            </a:solidFill>
+          </a:ln>
+        </p:spPr>
+        <p:style>
+          <a:lnRef idx="1">
+            <a:schemeClr val="accent1"/>
+          </a:lnRef>
+          <a:fillRef idx="3">
+            <a:schemeClr val="accent1"/>
+          </a:fillRef>
+          <a:effectRef idx="2">
+            <a:schemeClr val="accent1"/>
+          </a:effectRef>
+          <a:fontRef idx="minor">
+            <a:schemeClr val="lt1"/>
+          </a:fontRef>
+        </p:style>
+        <p:txBody>
+          <a:bodyPr rtlCol="0" anchor="ctr"/>
+          <a:lstStyle/>
+          <a:p>
+            <a:pPr algn="ctr"/>
+          </a:p>
+        </p:txBody>
+      </p:sp>
+      <p:sp>
+        <p:nvSpPr>
+          <p:cNvPr id="9" name="TextBox 8"/>
+          <p:cNvSpPr txBox="1"/>
+          <p:nvPr/>
+        </p:nvSpPr>
+        <p:spPr>
+          <a:xfrm>
+            <a:off x="3383280" y="914400"/>
+            <a:ext cx="2560320" cy="685800"/>
+          </a:xfrm>
+          <a:prstGeom prst="rect">
+            <a:avLst/>
+          </a:prstGeom>
+          <a:noFill/>
+        </p:spPr>
+        <p:txBody>
+          <a:bodyPr wrap="square">
+            <a:spAutoFit/>
+          </a:bodyPr>
+          <a:lstStyle/>
+          <a:p>
+            <a:pPr algn="ctr"/>
+            <a:r>
+              <a:rPr sz="3000" b="1" i="0">
+                <a:solidFill>
+                  <a:srgbClr val="FF8F00"/>
+                </a:solidFill>
+                <a:latin typeface="Calibri"/>
+              </a:rPr>
+              <a:t>6,2%</a:t>
+            </a:r>
+          </a:p>
+        </p:txBody>
+      </p:sp>
+      <p:sp>
+        <p:nvSpPr>
+          <p:cNvPr id="10" name="TextBox 9"/>
+          <p:cNvSpPr txBox="1"/>
+          <p:nvPr/>
+        </p:nvSpPr>
+        <p:spPr>
+          <a:xfrm>
+            <a:off x="3383280" y="1600200"/>
+            <a:ext cx="2560320" cy="548640"/>
+          </a:xfrm>
+          <a:prstGeom prst="rect">
+            <a:avLst/>
+          </a:prstGeom>
+          <a:noFill/>
+        </p:spPr>
+        <p:txBody>
+          <a:bodyPr wrap="square">
+            <a:spAutoFit/>
+          </a:bodyPr>
+          <a:lstStyle/>
+          <a:p>
+            <a:pPr algn="ctr"/>
+            <a:r>
+              <a:rPr sz="1100" b="0" i="0">
+                <a:solidFill>
+                  <a:srgbClr val="FFFFFF"/>
+                </a:solidFill>
+                <a:latin typeface="Calibri"/>
+              </a:rPr>
+              <a:t>Discriminação pura
+(M4 HLM)</a:t>
+            </a:r>
+          </a:p>
+        </p:txBody>
+      </p:sp>
+      <p:sp>
+        <p:nvSpPr>
+          <p:cNvPr id="11" name="Rectangle 10"/>
+          <p:cNvSpPr/>
+          <p:nvPr/>
+        </p:nvSpPr>
+        <p:spPr>
+          <a:xfrm>
+            <a:off x="6217920" y="868680"/>
+            <a:ext cx="2743200" cy="1371600"/>
+          </a:xfrm>
+          <a:prstGeom prst="rect">
+            <a:avLst/>
+          </a:prstGeom>
+          <a:solidFill>
+            <a:srgbClr val="1A305C"/>
+          </a:solidFill>
+          <a:ln w="12700">
+            <a:solidFill>
+              <a:srgbClr val="FF8F00"/>
+            </a:solidFill>
+          </a:ln>
+        </p:spPr>
+        <p:style>
+          <a:lnRef idx="1">
+            <a:schemeClr val="accent1"/>
+          </a:lnRef>
+          <a:fillRef idx="3">
+            <a:schemeClr val="accent1"/>
+          </a:fillRef>
+          <a:effectRef idx="2">
+            <a:schemeClr val="accent1"/>
+          </a:effectRef>
+          <a:fontRef idx="minor">
+            <a:schemeClr val="lt1"/>
+          </a:fontRef>
+        </p:style>
+        <p:txBody>
+          <a:bodyPr rtlCol="0" anchor="ctr"/>
+          <a:lstStyle/>
+          <a:p>
+            <a:pPr algn="ctr"/>
+          </a:p>
+        </p:txBody>
+      </p:sp>
+      <p:sp>
+        <p:nvSpPr>
+          <p:cNvPr id="12" name="TextBox 11"/>
+          <p:cNvSpPr txBox="1"/>
+          <p:nvPr/>
+        </p:nvSpPr>
+        <p:spPr>
+          <a:xfrm>
+            <a:off x="6309360" y="914400"/>
+            <a:ext cx="2560320" cy="685800"/>
+          </a:xfrm>
+          <a:prstGeom prst="rect">
+            <a:avLst/>
+          </a:prstGeom>
+          <a:noFill/>
+        </p:spPr>
+        <p:txBody>
+          <a:bodyPr wrap="square">
+            <a:spAutoFit/>
+          </a:bodyPr>
+          <a:lstStyle/>
+          <a:p>
+            <a:pPr algn="ctr"/>
+            <a:r>
+              <a:rPr sz="3000" b="1" i="0">
+                <a:solidFill>
+                  <a:srgbClr val="FF8F00"/>
+                </a:solidFill>
+                <a:latin typeface="Calibri"/>
+              </a:rPr>
+              <a:t>OR=0,693</a:t>
+            </a:r>
+          </a:p>
+        </p:txBody>
+      </p:sp>
+      <p:sp>
+        <p:nvSpPr>
+          <p:cNvPr id="13" name="TextBox 12"/>
+          <p:cNvSpPr txBox="1"/>
+          <p:nvPr/>
+        </p:nvSpPr>
+        <p:spPr>
+          <a:xfrm>
+            <a:off x="6309360" y="1600200"/>
+            <a:ext cx="2560320" cy="548640"/>
+          </a:xfrm>
+          <a:prstGeom prst="rect">
+            <a:avLst/>
+          </a:prstGeom>
+          <a:noFill/>
+        </p:spPr>
+        <p:txBody>
+          <a:bodyPr wrap="square">
+            <a:spAutoFit/>
+          </a:bodyPr>
+          <a:lstStyle/>
+          <a:p>
+            <a:pPr algn="ctr"/>
+            <a:r>
+              <a:rPr sz="1100" b="0" i="0">
+                <a:solidFill>
+                  <a:srgbClr val="FFFFFF"/>
+                </a:solidFill>
+                <a:latin typeface="Calibri"/>
+              </a:rPr>
+              <a:t>Acesso qualificado
+(GLMM M2, lme4)</a:t>
+            </a:r>
+          </a:p>
+        </p:txBody>
+      </p:sp>
+      <p:sp>
+        <p:nvSpPr>
+          <p:cNvPr id="14" name="Rectangle 13"/>
+          <p:cNvSpPr/>
+          <p:nvPr/>
+        </p:nvSpPr>
+        <p:spPr>
+          <a:xfrm>
+            <a:off x="9144000" y="868680"/>
+            <a:ext cx="2743200" cy="1371600"/>
+          </a:xfrm>
+          <a:prstGeom prst="rect">
+            <a:avLst/>
+          </a:prstGeom>
+          <a:solidFill>
+            <a:srgbClr val="1A305C"/>
+          </a:solidFill>
+          <a:ln w="12700">
+            <a:solidFill>
+              <a:srgbClr val="FF8F00"/>
+            </a:solidFill>
+          </a:ln>
+        </p:spPr>
+        <p:style>
+          <a:lnRef idx="1">
+            <a:schemeClr val="accent1"/>
+          </a:lnRef>
+          <a:fillRef idx="3">
+            <a:schemeClr val="accent1"/>
+          </a:fillRef>
+          <a:effectRef idx="2">
+            <a:schemeClr val="accent1"/>
+          </a:effectRef>
+          <a:fontRef idx="minor">
+            <a:schemeClr val="lt1"/>
+          </a:fontRef>
+        </p:style>
+        <p:txBody>
+          <a:bodyPr rtlCol="0" anchor="ctr"/>
+          <a:lstStyle/>
+          <a:p>
+            <a:pPr algn="ctr"/>
+          </a:p>
+        </p:txBody>
+      </p:sp>
+      <p:sp>
+        <p:nvSpPr>
+          <p:cNvPr id="15" name="TextBox 14"/>
+          <p:cNvSpPr txBox="1"/>
+          <p:nvPr/>
+        </p:nvSpPr>
+        <p:spPr>
+          <a:xfrm>
+            <a:off x="9235440" y="914400"/>
+            <a:ext cx="2560320" cy="685800"/>
+          </a:xfrm>
+          <a:prstGeom prst="rect">
+            <a:avLst/>
+          </a:prstGeom>
+          <a:noFill/>
+        </p:spPr>
+        <p:txBody>
+          <a:bodyPr wrap="square">
+            <a:spAutoFit/>
+          </a:bodyPr>
+          <a:lstStyle/>
+          <a:p>
+            <a:pPr algn="ctr"/>
+            <a:r>
+              <a:rPr sz="3000" b="1" i="0">
+                <a:solidFill>
+                  <a:srgbClr val="FF8F00"/>
+                </a:solidFill>
+                <a:latin typeface="Calibri"/>
+              </a:rPr>
+              <a:t>χ²=191k</a:t>
+            </a:r>
+          </a:p>
+        </p:txBody>
+      </p:sp>
+      <p:sp>
+        <p:nvSpPr>
+          <p:cNvPr id="16" name="TextBox 15"/>
+          <p:cNvSpPr txBox="1"/>
+          <p:nvPr/>
+        </p:nvSpPr>
+        <p:spPr>
+          <a:xfrm>
+            <a:off x="9235440" y="1600200"/>
+            <a:ext cx="2560320" cy="548640"/>
+          </a:xfrm>
+          <a:prstGeom prst="rect">
+            <a:avLst/>
+          </a:prstGeom>
+          <a:noFill/>
+        </p:spPr>
+        <p:txBody>
+          <a:bodyPr wrap="square">
+            <a:spAutoFit/>
+          </a:bodyPr>
+          <a:lstStyle/>
+          <a:p>
+            <a:pPr algn="ctr"/>
+            <a:r>
+              <a:rPr sz="1100" b="0" i="0">
+                <a:solidFill>
+                  <a:srgbClr val="FFFFFF"/>
+                </a:solidFill>
+                <a:latin typeface="Calibri"/>
+              </a:rPr>
+              <a:t>LRT confirma
+hierarquia UPA</a:t>
+            </a:r>
+          </a:p>
+        </p:txBody>
+      </p:sp>
+      <p:sp>
+        <p:nvSpPr>
+          <p:cNvPr id="17" name="Rectangle 16"/>
+          <p:cNvSpPr/>
+          <p:nvPr/>
+        </p:nvSpPr>
+        <p:spPr>
+          <a:xfrm>
+            <a:off x="274320" y="2377440"/>
+            <a:ext cx="11612880" cy="749808"/>
+          </a:xfrm>
+          <a:prstGeom prst="rect">
+            <a:avLst/>
+          </a:prstGeom>
+          <a:solidFill>
+            <a:srgbClr val="0F274A"/>
+          </a:solidFill>
+          <a:ln w="7620">
+            <a:solidFill>
+              <a:srgbClr val="FF8F00"/>
+            </a:solidFill>
+          </a:ln>
+        </p:spPr>
+        <p:style>
+          <a:lnRef idx="1">
+            <a:schemeClr val="accent1"/>
+          </a:lnRef>
+          <a:fillRef idx="3">
+            <a:schemeClr val="accent1"/>
+          </a:fillRef>
+          <a:effectRef idx="2">
+            <a:schemeClr val="accent1"/>
+          </a:effectRef>
+          <a:fontRef idx="minor">
+            <a:schemeClr val="lt1"/>
+          </a:fontRef>
+        </p:style>
+        <p:txBody>
+          <a:bodyPr rtlCol="0" anchor="ctr"/>
+          <a:lstStyle/>
+          <a:p>
+            <a:pPr algn="ctr"/>
+          </a:p>
+        </p:txBody>
+      </p:sp>
+      <p:sp>
+        <p:nvSpPr>
+          <p:cNvPr id="18" name="TextBox 17"/>
+          <p:cNvSpPr txBox="1"/>
+          <p:nvPr/>
+        </p:nvSpPr>
+        <p:spPr>
+          <a:xfrm>
+            <a:off x="457200" y="2423160"/>
+            <a:ext cx="11247120" cy="685800"/>
+          </a:xfrm>
+          <a:prstGeom prst="rect">
+            <a:avLst/>
+          </a:prstGeom>
+          <a:noFill/>
+        </p:spPr>
+        <p:txBody>
+          <a:bodyPr wrap="square">
+            <a:spAutoFit/>
+          </a:bodyPr>
+          <a:lstStyle/>
+          <a:p>
+            <a:pPr algn="l"/>
+            <a:r>
+              <a:rPr sz="1300" b="0" i="0">
+                <a:solidFill>
+                  <a:srgbClr val="FFFFFF"/>
+                </a:solidFill>
+                <a:latin typeface="Calibri"/>
+              </a:rPr>
+              <a:t>1. A desigualdade racial no mercado de trabalho brasileiro é estrutural, multicausal e resistente à convergência espontânea.</a:t>
+            </a:r>
+          </a:p>
+        </p:txBody>
+      </p:sp>
+      <p:sp>
+        <p:nvSpPr>
+          <p:cNvPr id="19" name="Rectangle 18"/>
+          <p:cNvSpPr/>
+          <p:nvPr/>
+        </p:nvSpPr>
+        <p:spPr>
+          <a:xfrm>
+            <a:off x="274320" y="3246120"/>
+            <a:ext cx="11612880" cy="749808"/>
+          </a:xfrm>
+          <a:prstGeom prst="rect">
+            <a:avLst/>
+          </a:prstGeom>
+          <a:solidFill>
+            <a:srgbClr val="0F274A"/>
+          </a:solidFill>
+          <a:ln w="7620">
+            <a:solidFill>
+              <a:srgbClr val="1565C0"/>
+            </a:solidFill>
+          </a:ln>
+        </p:spPr>
+        <p:style>
+          <a:lnRef idx="1">
+            <a:schemeClr val="accent1"/>
+          </a:lnRef>
+          <a:fillRef idx="3">
+            <a:schemeClr val="accent1"/>
+          </a:fillRef>
+          <a:effectRef idx="2">
+            <a:schemeClr val="accent1"/>
+          </a:effectRef>
+          <a:fontRef idx="minor">
+            <a:schemeClr val="lt1"/>
+          </a:fontRef>
+        </p:style>
+        <p:txBody>
+          <a:bodyPr rtlCol="0" anchor="ctr"/>
+          <a:lstStyle/>
+          <a:p>
+            <a:pPr algn="ctr"/>
+          </a:p>
+        </p:txBody>
+      </p:sp>
+      <p:sp>
+        <p:nvSpPr>
+          <p:cNvPr id="20" name="TextBox 19"/>
+          <p:cNvSpPr txBox="1"/>
+          <p:nvPr/>
+        </p:nvSpPr>
+        <p:spPr>
+          <a:xfrm>
+            <a:off x="457200" y="3291840"/>
+            <a:ext cx="11247120" cy="685800"/>
+          </a:xfrm>
+          <a:prstGeom prst="rect">
+            <a:avLst/>
+          </a:prstGeom>
+          <a:noFill/>
+        </p:spPr>
+        <p:txBody>
+          <a:bodyPr wrap="square">
+            <a:spAutoFit/>
+          </a:bodyPr>
+          <a:lstStyle/>
+          <a:p>
+            <a:pPr algn="l"/>
+            <a:r>
+              <a:rPr sz="1300" b="0" i="0">
+                <a:solidFill>
+                  <a:srgbClr val="FFFFFF"/>
+                </a:solidFill>
+                <a:latin typeface="Calibri"/>
+              </a:rPr>
+              <a:t>2. A discriminação opera em dois estágios independentes: barreiras de ACESSO a ocupações qualificadas (GLMM: OR=0,693, AME=−4,73 p.p.) e discriminação de REMUNERAÇÃO dentro das mesmas funções (HLM M4: 6,2%).</a:t>
+            </a:r>
+          </a:p>
+        </p:txBody>
+      </p:sp>
+      <p:sp>
+        <p:nvSpPr>
+          <p:cNvPr id="21" name="Rectangle 20"/>
+          <p:cNvSpPr/>
+          <p:nvPr/>
+        </p:nvSpPr>
+        <p:spPr>
+          <a:xfrm>
+            <a:off x="274320" y="4114800"/>
+            <a:ext cx="11612880" cy="749808"/>
+          </a:xfrm>
+          <a:prstGeom prst="rect">
+            <a:avLst/>
+          </a:prstGeom>
+          <a:solidFill>
+            <a:srgbClr val="0F274A"/>
+          </a:solidFill>
+          <a:ln w="7620">
+            <a:solidFill>
+              <a:srgbClr val="1565C0"/>
+            </a:solidFill>
+          </a:ln>
+        </p:spPr>
+        <p:style>
+          <a:lnRef idx="1">
+            <a:schemeClr val="accent1"/>
+          </a:lnRef>
+          <a:fillRef idx="3">
+            <a:schemeClr val="accent1"/>
+          </a:fillRef>
+          <a:effectRef idx="2">
+            <a:schemeClr val="accent1"/>
+          </a:effectRef>
+          <a:fontRef idx="minor">
+            <a:schemeClr val="lt1"/>
+          </a:fontRef>
+        </p:style>
+        <p:txBody>
+          <a:bodyPr rtlCol="0" anchor="ctr"/>
+          <a:lstStyle/>
+          <a:p>
+            <a:pPr algn="ctr"/>
+          </a:p>
+        </p:txBody>
+      </p:sp>
+      <p:sp>
+        <p:nvSpPr>
+          <p:cNvPr id="22" name="TextBox 21"/>
+          <p:cNvSpPr txBox="1"/>
+          <p:nvPr/>
+        </p:nvSpPr>
+        <p:spPr>
+          <a:xfrm>
+            <a:off x="457200" y="4160520"/>
+            <a:ext cx="11247120" cy="685800"/>
+          </a:xfrm>
+          <a:prstGeom prst="rect">
+            <a:avLst/>
+          </a:prstGeom>
+          <a:noFill/>
+        </p:spPr>
+        <p:txBody>
+          <a:bodyPr wrap="square">
+            <a:spAutoFit/>
+          </a:bodyPr>
+          <a:lstStyle/>
+          <a:p>
+            <a:pPr algn="l"/>
+            <a:r>
+              <a:rPr sz="1300" b="0" i="0">
+                <a:solidFill>
+                  <a:srgbClr val="FFFFFF"/>
+                </a:solidFill>
+                <a:latin typeface="Calibri"/>
+              </a:rPr>
+              <a:t>3. O glass ceiling racial é real e crescente no topo da distribuição — confirmado formalmente pela regressão quantílica e consistente com o IR=0,47 nas capitais.</a:t>
+            </a:r>
+          </a:p>
+        </p:txBody>
+      </p:sp>
+      <p:sp>
+        <p:nvSpPr>
+          <p:cNvPr id="23" name="Rectangle 22"/>
+          <p:cNvSpPr/>
+          <p:nvPr/>
+        </p:nvSpPr>
+        <p:spPr>
+          <a:xfrm>
+            <a:off x="274320" y="4983480"/>
+            <a:ext cx="11612880" cy="749808"/>
+          </a:xfrm>
+          <a:prstGeom prst="rect">
+            <a:avLst/>
+          </a:prstGeom>
+          <a:solidFill>
+            <a:srgbClr val="0F274A"/>
+          </a:solidFill>
+          <a:ln w="7620">
+            <a:solidFill>
+              <a:srgbClr val="1565C0"/>
+            </a:solidFill>
+          </a:ln>
+        </p:spPr>
+        <p:style>
+          <a:lnRef idx="1">
+            <a:schemeClr val="accent1"/>
+          </a:lnRef>
+          <a:fillRef idx="3">
+            <a:schemeClr val="accent1"/>
+          </a:fillRef>
+          <a:effectRef idx="2">
+            <a:schemeClr val="accent1"/>
+          </a:effectRef>
+          <a:fontRef idx="minor">
+            <a:schemeClr val="lt1"/>
+          </a:fontRef>
+        </p:style>
+        <p:txBody>
+          <a:bodyPr rtlCol="0" anchor="ctr"/>
+          <a:lstStyle/>
+          <a:p>
+            <a:pPr algn="ctr"/>
+          </a:p>
+        </p:txBody>
+      </p:sp>
+      <p:sp>
+        <p:nvSpPr>
+          <p:cNvPr id="24" name="TextBox 23"/>
+          <p:cNvSpPr txBox="1"/>
+          <p:nvPr/>
+        </p:nvSpPr>
+        <p:spPr>
+          <a:xfrm>
+            <a:off x="457200" y="5029200"/>
+            <a:ext cx="11247120" cy="685800"/>
+          </a:xfrm>
+          <a:prstGeom prst="rect">
+            <a:avLst/>
+          </a:prstGeom>
+          <a:noFill/>
+        </p:spPr>
+        <p:txBody>
+          <a:bodyPr wrap="square">
+            <a:spAutoFit/>
+          </a:bodyPr>
+          <a:lstStyle/>
+          <a:p>
+            <a:pPr algn="l"/>
+            <a:r>
+              <a:rPr sz="1300" b="0" i="0">
+                <a:solidFill>
+                  <a:srgbClr val="FFFFFF"/>
+                </a:solidFill>
+                <a:latin typeface="Calibri"/>
+              </a:rPr>
+              <a:t>4. Políticas que atuam apenas no gap salarial direto atacam 16% do problema. Os 84% restantes requerem ação nas portas de entrada das ocupações de alto prestígio.</a:t>
+            </a:r>
+          </a:p>
+        </p:txBody>
+      </p:sp>
+      <p:sp>
+        <p:nvSpPr>
+          <p:cNvPr id="25" name="Rectangle 24"/>
+          <p:cNvSpPr/>
+          <p:nvPr/>
+        </p:nvSpPr>
+        <p:spPr>
+          <a:xfrm>
+            <a:off x="0" y="6400800"/>
+            <a:ext cx="12188952" cy="457200"/>
+          </a:xfrm>
+          <a:prstGeom prst="rect">
+            <a:avLst/>
+          </a:prstGeom>
+          <a:solidFill>
+            <a:srgbClr val="0D1F3C"/>
+          </a:solidFill>
+          <a:ln/>
+        </p:spPr>
+        <p:style>
+          <a:lnRef idx="1">
+            <a:schemeClr val="accent1"/>
+          </a:lnRef>
+          <a:fillRef idx="3">
+            <a:schemeClr val="accent1"/>
+          </a:fillRef>
+          <a:effectRef idx="2">
+            <a:schemeClr val="accent1"/>
+          </a:effectRef>
+          <a:fontRef idx="minor">
+            <a:schemeClr val="lt1"/>
+          </a:fontRef>
+        </p:style>
+        <p:txBody>
+          <a:bodyPr rtlCol="0" anchor="ctr"/>
+          <a:lstStyle/>
+          <a:p>
+            <a:pPr algn="ctr"/>
+          </a:p>
+        </p:txBody>
+      </p:sp>
+      <p:sp>
+        <p:nvSpPr>
+          <p:cNvPr id="26" name="TextBox 25"/>
+          <p:cNvSpPr txBox="1"/>
+          <p:nvPr/>
+        </p:nvSpPr>
+        <p:spPr>
+          <a:xfrm>
+            <a:off x="274320" y="6446520"/>
+            <a:ext cx="11612880" cy="365760"/>
+          </a:xfrm>
+          <a:prstGeom prst="rect">
+            <a:avLst/>
+          </a:prstGeom>
+          <a:noFill/>
+        </p:spPr>
+        <p:txBody>
+          <a:bodyPr wrap="square">
+            <a:spAutoFit/>
+          </a:bodyPr>
+          <a:lstStyle/>
+          <a:p>
+            <a:pPr algn="ctr"/>
+            <a:r>
+              <a:rPr sz="1100" b="0" i="0">
+                <a:solidFill>
+                  <a:srgbClr val="90A4AE"/>
+                </a:solidFill>
+                <a:latin typeface="Calibri"/>
+              </a:rPr>
+              <a:t>Ricardo Calheiros  |  MBA Data Science &amp; Analytics  |  USP/ESALQ  |  rickinrj@gmail.com</a:t>
             </a:r>
           </a:p>
         </p:txBody>
@@ -25636,7 +26522,7 @@
                 </a:solidFill>
                 <a:latin typeface="Calibri"/>
               </a:rPr>
-              <a:t>4/28</a:t>
+              <a:t>4/29</a:t>
             </a:r>
           </a:p>
         </p:txBody>
@@ -27161,7 +28047,7 @@
                 </a:solidFill>
                 <a:latin typeface="Calibri"/>
               </a:rPr>
-              <a:t>5/28</a:t>
+              <a:t>5/29</a:t>
             </a:r>
           </a:p>
         </p:txBody>
@@ -28221,7 +29107,7 @@
                 </a:solidFill>
                 <a:latin typeface="Calibri"/>
               </a:rPr>
-              <a:t>6/28</a:t>
+              <a:t>6/29</a:t>
             </a:r>
           </a:p>
         </p:txBody>
@@ -28589,7 +29475,7 @@
                 </a:solidFill>
                 <a:latin typeface="Calibri"/>
               </a:rPr>
-              <a:t>7/28</a:t>
+              <a:t>7/29</a:t>
             </a:r>
           </a:p>
         </p:txBody>
@@ -29103,7 +29989,7 @@
                 </a:solidFill>
                 <a:latin typeface="Calibri"/>
               </a:rPr>
-              <a:t>8/28</a:t>
+              <a:t>8/29</a:t>
             </a:r>
           </a:p>
         </p:txBody>
@@ -30057,7 +30943,7 @@
                 </a:solidFill>
                 <a:latin typeface="Calibri"/>
               </a:rPr>
-              <a:t>9/28</a:t>
+              <a:t>9/29</a:t>
             </a:r>
           </a:p>
         </p:txBody>

</xml_diff>